<commit_message>
create: create equipment type modal window
</commit_message>
<xml_diff>
--- a/docs/Предзащита.pptx
+++ b/docs/Предзащита.pptx
@@ -5,7 +5,7 @@
     <p:sldMasterId id="2147483679" r:id="rId1"/>
   </p:sldMasterIdLst>
   <p:notesMasterIdLst>
-    <p:notesMasterId r:id="rId16"/>
+    <p:notesMasterId r:id="rId19"/>
   </p:notesMasterIdLst>
   <p:sldIdLst>
     <p:sldId id="256" r:id="rId2"/>
@@ -19,49 +19,52 @@
     <p:sldId id="313" r:id="rId10"/>
     <p:sldId id="314" r:id="rId11"/>
     <p:sldId id="315" r:id="rId12"/>
-    <p:sldId id="316" r:id="rId13"/>
-    <p:sldId id="318" r:id="rId14"/>
+    <p:sldId id="318" r:id="rId13"/>
+    <p:sldId id="319" r:id="rId14"/>
     <p:sldId id="317" r:id="rId15"/>
+    <p:sldId id="320" r:id="rId16"/>
+    <p:sldId id="321" r:id="rId17"/>
+    <p:sldId id="322" r:id="rId18"/>
   </p:sldIdLst>
   <p:sldSz cx="9144000" cy="5143500" type="screen16x9"/>
   <p:notesSz cx="6858000" cy="9144000"/>
   <p:embeddedFontLst>
     <p:embeddedFont>
       <p:font typeface="Calibri" panose="020F0502020204030204" pitchFamily="34" charset="0"/>
-      <p:regular r:id="rId17"/>
-      <p:bold r:id="rId18"/>
-      <p:italic r:id="rId19"/>
-      <p:boldItalic r:id="rId20"/>
+      <p:regular r:id="rId20"/>
+      <p:bold r:id="rId21"/>
+      <p:italic r:id="rId22"/>
+      <p:boldItalic r:id="rId23"/>
     </p:embeddedFont>
     <p:embeddedFont>
       <p:font typeface="Figtree" panose="020B0604020202020204" charset="0"/>
-      <p:regular r:id="rId21"/>
-      <p:bold r:id="rId22"/>
-      <p:italic r:id="rId23"/>
-      <p:boldItalic r:id="rId24"/>
+      <p:regular r:id="rId24"/>
+      <p:bold r:id="rId25"/>
+      <p:italic r:id="rId26"/>
+      <p:boldItalic r:id="rId27"/>
     </p:embeddedFont>
     <p:embeddedFont>
       <p:font typeface="Lato" panose="020F0502020204030203" pitchFamily="34" charset="0"/>
-      <p:regular r:id="rId25"/>
-      <p:bold r:id="rId26"/>
-      <p:italic r:id="rId27"/>
-      <p:boldItalic r:id="rId28"/>
+      <p:regular r:id="rId28"/>
+      <p:bold r:id="rId29"/>
+      <p:italic r:id="rId30"/>
+      <p:boldItalic r:id="rId31"/>
     </p:embeddedFont>
     <p:embeddedFont>
       <p:font typeface="Open Sans" panose="020B0606030504020204" pitchFamily="34" charset="0"/>
-      <p:regular r:id="rId29"/>
-      <p:bold r:id="rId30"/>
-      <p:italic r:id="rId31"/>
-      <p:boldItalic r:id="rId32"/>
+      <p:regular r:id="rId32"/>
+      <p:bold r:id="rId33"/>
+      <p:italic r:id="rId34"/>
+      <p:boldItalic r:id="rId35"/>
     </p:embeddedFont>
     <p:embeddedFont>
       <p:font typeface="Sora" panose="020B0604020202020204" charset="0"/>
-      <p:regular r:id="rId33"/>
-      <p:bold r:id="rId34"/>
+      <p:regular r:id="rId36"/>
+      <p:bold r:id="rId37"/>
     </p:embeddedFont>
     <p:embeddedFont>
       <p:font typeface="Sora ExtraBold" panose="020B0604020202020204" charset="0"/>
-      <p:bold r:id="rId35"/>
+      <p:bold r:id="rId38"/>
     </p:embeddedFont>
   </p:embeddedFontLst>
   <p:defaultTextStyle>
@@ -1174,7 +1177,7 @@
     </p:spTree>
     <p:extLst>
       <p:ext uri="{BB962C8B-B14F-4D97-AF65-F5344CB8AC3E}">
-        <p14:creationId xmlns:p14="http://schemas.microsoft.com/office/powerpoint/2010/main" val="3761952012"/>
+        <p14:creationId xmlns:p14="http://schemas.microsoft.com/office/powerpoint/2010/main" val="664003728"/>
       </p:ext>
     </p:extLst>
   </p:cSld>
@@ -1283,7 +1286,7 @@
     </p:spTree>
     <p:extLst>
       <p:ext uri="{BB962C8B-B14F-4D97-AF65-F5344CB8AC3E}">
-        <p14:creationId xmlns:p14="http://schemas.microsoft.com/office/powerpoint/2010/main" val="664003728"/>
+        <p14:creationId xmlns:p14="http://schemas.microsoft.com/office/powerpoint/2010/main" val="1577733956"/>
       </p:ext>
     </p:extLst>
   </p:cSld>
@@ -1393,6 +1396,333 @@
     <p:extLst>
       <p:ext uri="{BB962C8B-B14F-4D97-AF65-F5344CB8AC3E}">
         <p14:creationId xmlns:p14="http://schemas.microsoft.com/office/powerpoint/2010/main" val="3020110829"/>
+      </p:ext>
+    </p:extLst>
+  </p:cSld>
+  <p:clrMapOvr>
+    <a:masterClrMapping/>
+  </p:clrMapOvr>
+</p:notes>
+</file>
+
+<file path=ppt/notesSlides/notesSlide15.xml><?xml version="1.0" encoding="utf-8"?>
+<p:notes xmlns:a="http://schemas.openxmlformats.org/drawingml/2006/main" xmlns:r="http://schemas.openxmlformats.org/officeDocument/2006/relationships" xmlns:p="http://schemas.openxmlformats.org/presentationml/2006/main" showMasterSp="0" showMasterPhAnim="0">
+  <p:cSld>
+    <p:spTree>
+      <p:nvGrpSpPr>
+        <p:cNvPr id="1" name="Shape 935"/>
+        <p:cNvGrpSpPr/>
+        <p:nvPr/>
+      </p:nvGrpSpPr>
+      <p:grpSpPr>
+        <a:xfrm>
+          <a:off x="0" y="0"/>
+          <a:ext cx="0" cy="0"/>
+          <a:chOff x="0" y="0"/>
+          <a:chExt cx="0" cy="0"/>
+        </a:xfrm>
+      </p:grpSpPr>
+      <p:sp>
+        <p:nvSpPr>
+          <p:cNvPr id="936" name="Google Shape;936;g20f41e19245_0_19:notes"/>
+          <p:cNvSpPr>
+            <a:spLocks noGrp="1" noRot="1" noChangeAspect="1"/>
+          </p:cNvSpPr>
+          <p:nvPr>
+            <p:ph type="sldImg" idx="2"/>
+          </p:nvPr>
+        </p:nvSpPr>
+        <p:spPr>
+          <a:xfrm>
+            <a:off x="381000" y="685800"/>
+            <a:ext cx="6096000" cy="3429000"/>
+          </a:xfrm>
+          <a:custGeom>
+            <a:avLst/>
+            <a:gdLst/>
+            <a:ahLst/>
+            <a:cxnLst/>
+            <a:rect l="l" t="t" r="r" b="b"/>
+            <a:pathLst>
+              <a:path w="120000" h="120000" extrusionOk="0">
+                <a:moveTo>
+                  <a:pt x="0" y="0"/>
+                </a:moveTo>
+                <a:lnTo>
+                  <a:pt x="120000" y="0"/>
+                </a:lnTo>
+                <a:lnTo>
+                  <a:pt x="120000" y="120000"/>
+                </a:lnTo>
+                <a:lnTo>
+                  <a:pt x="0" y="120000"/>
+                </a:lnTo>
+                <a:close/>
+              </a:path>
+            </a:pathLst>
+          </a:custGeom>
+        </p:spPr>
+      </p:sp>
+      <p:sp>
+        <p:nvSpPr>
+          <p:cNvPr id="937" name="Google Shape;937;g20f41e19245_0_19:notes"/>
+          <p:cNvSpPr txBox="1">
+            <a:spLocks noGrp="1"/>
+          </p:cNvSpPr>
+          <p:nvPr>
+            <p:ph type="body" idx="1"/>
+          </p:nvPr>
+        </p:nvSpPr>
+        <p:spPr>
+          <a:xfrm>
+            <a:off x="685800" y="4343400"/>
+            <a:ext cx="5486400" cy="4114800"/>
+          </a:xfrm>
+          <a:prstGeom prst="rect">
+            <a:avLst/>
+          </a:prstGeom>
+        </p:spPr>
+        <p:txBody>
+          <a:bodyPr spcFirstLastPara="1" wrap="square" lIns="91425" tIns="91425" rIns="91425" bIns="91425" anchor="t" anchorCtr="0">
+            <a:noAutofit/>
+          </a:bodyPr>
+          <a:lstStyle/>
+          <a:p>
+            <a:pPr marL="0" lvl="0" indent="0" algn="l" rtl="0">
+              <a:spcBef>
+                <a:spcPts val="0"/>
+              </a:spcBef>
+              <a:spcAft>
+                <a:spcPts val="0"/>
+              </a:spcAft>
+              <a:buNone/>
+            </a:pPr>
+            <a:endParaRPr/>
+          </a:p>
+        </p:txBody>
+      </p:sp>
+    </p:spTree>
+    <p:extLst>
+      <p:ext uri="{BB962C8B-B14F-4D97-AF65-F5344CB8AC3E}">
+        <p14:creationId xmlns:p14="http://schemas.microsoft.com/office/powerpoint/2010/main" val="565982437"/>
+      </p:ext>
+    </p:extLst>
+  </p:cSld>
+  <p:clrMapOvr>
+    <a:masterClrMapping/>
+  </p:clrMapOvr>
+</p:notes>
+</file>
+
+<file path=ppt/notesSlides/notesSlide16.xml><?xml version="1.0" encoding="utf-8"?>
+<p:notes xmlns:a="http://schemas.openxmlformats.org/drawingml/2006/main" xmlns:r="http://schemas.openxmlformats.org/officeDocument/2006/relationships" xmlns:p="http://schemas.openxmlformats.org/presentationml/2006/main" showMasterSp="0" showMasterPhAnim="0">
+  <p:cSld>
+    <p:spTree>
+      <p:nvGrpSpPr>
+        <p:cNvPr id="1" name="Shape 935"/>
+        <p:cNvGrpSpPr/>
+        <p:nvPr/>
+      </p:nvGrpSpPr>
+      <p:grpSpPr>
+        <a:xfrm>
+          <a:off x="0" y="0"/>
+          <a:ext cx="0" cy="0"/>
+          <a:chOff x="0" y="0"/>
+          <a:chExt cx="0" cy="0"/>
+        </a:xfrm>
+      </p:grpSpPr>
+      <p:sp>
+        <p:nvSpPr>
+          <p:cNvPr id="936" name="Google Shape;936;g20f41e19245_0_19:notes"/>
+          <p:cNvSpPr>
+            <a:spLocks noGrp="1" noRot="1" noChangeAspect="1"/>
+          </p:cNvSpPr>
+          <p:nvPr>
+            <p:ph type="sldImg" idx="2"/>
+          </p:nvPr>
+        </p:nvSpPr>
+        <p:spPr>
+          <a:xfrm>
+            <a:off x="381000" y="685800"/>
+            <a:ext cx="6096000" cy="3429000"/>
+          </a:xfrm>
+          <a:custGeom>
+            <a:avLst/>
+            <a:gdLst/>
+            <a:ahLst/>
+            <a:cxnLst/>
+            <a:rect l="l" t="t" r="r" b="b"/>
+            <a:pathLst>
+              <a:path w="120000" h="120000" extrusionOk="0">
+                <a:moveTo>
+                  <a:pt x="0" y="0"/>
+                </a:moveTo>
+                <a:lnTo>
+                  <a:pt x="120000" y="0"/>
+                </a:lnTo>
+                <a:lnTo>
+                  <a:pt x="120000" y="120000"/>
+                </a:lnTo>
+                <a:lnTo>
+                  <a:pt x="0" y="120000"/>
+                </a:lnTo>
+                <a:close/>
+              </a:path>
+            </a:pathLst>
+          </a:custGeom>
+        </p:spPr>
+      </p:sp>
+      <p:sp>
+        <p:nvSpPr>
+          <p:cNvPr id="937" name="Google Shape;937;g20f41e19245_0_19:notes"/>
+          <p:cNvSpPr txBox="1">
+            <a:spLocks noGrp="1"/>
+          </p:cNvSpPr>
+          <p:nvPr>
+            <p:ph type="body" idx="1"/>
+          </p:nvPr>
+        </p:nvSpPr>
+        <p:spPr>
+          <a:xfrm>
+            <a:off x="685800" y="4343400"/>
+            <a:ext cx="5486400" cy="4114800"/>
+          </a:xfrm>
+          <a:prstGeom prst="rect">
+            <a:avLst/>
+          </a:prstGeom>
+        </p:spPr>
+        <p:txBody>
+          <a:bodyPr spcFirstLastPara="1" wrap="square" lIns="91425" tIns="91425" rIns="91425" bIns="91425" anchor="t" anchorCtr="0">
+            <a:noAutofit/>
+          </a:bodyPr>
+          <a:lstStyle/>
+          <a:p>
+            <a:pPr marL="0" lvl="0" indent="0" algn="l" rtl="0">
+              <a:spcBef>
+                <a:spcPts val="0"/>
+              </a:spcBef>
+              <a:spcAft>
+                <a:spcPts val="0"/>
+              </a:spcAft>
+              <a:buNone/>
+            </a:pPr>
+            <a:endParaRPr/>
+          </a:p>
+        </p:txBody>
+      </p:sp>
+    </p:spTree>
+    <p:extLst>
+      <p:ext uri="{BB962C8B-B14F-4D97-AF65-F5344CB8AC3E}">
+        <p14:creationId xmlns:p14="http://schemas.microsoft.com/office/powerpoint/2010/main" val="3112489065"/>
+      </p:ext>
+    </p:extLst>
+  </p:cSld>
+  <p:clrMapOvr>
+    <a:masterClrMapping/>
+  </p:clrMapOvr>
+</p:notes>
+</file>
+
+<file path=ppt/notesSlides/notesSlide17.xml><?xml version="1.0" encoding="utf-8"?>
+<p:notes xmlns:a="http://schemas.openxmlformats.org/drawingml/2006/main" xmlns:r="http://schemas.openxmlformats.org/officeDocument/2006/relationships" xmlns:p="http://schemas.openxmlformats.org/presentationml/2006/main" showMasterSp="0" showMasterPhAnim="0">
+  <p:cSld>
+    <p:spTree>
+      <p:nvGrpSpPr>
+        <p:cNvPr id="1" name="Shape 935"/>
+        <p:cNvGrpSpPr/>
+        <p:nvPr/>
+      </p:nvGrpSpPr>
+      <p:grpSpPr>
+        <a:xfrm>
+          <a:off x="0" y="0"/>
+          <a:ext cx="0" cy="0"/>
+          <a:chOff x="0" y="0"/>
+          <a:chExt cx="0" cy="0"/>
+        </a:xfrm>
+      </p:grpSpPr>
+      <p:sp>
+        <p:nvSpPr>
+          <p:cNvPr id="936" name="Google Shape;936;g20f41e19245_0_19:notes"/>
+          <p:cNvSpPr>
+            <a:spLocks noGrp="1" noRot="1" noChangeAspect="1"/>
+          </p:cNvSpPr>
+          <p:nvPr>
+            <p:ph type="sldImg" idx="2"/>
+          </p:nvPr>
+        </p:nvSpPr>
+        <p:spPr>
+          <a:xfrm>
+            <a:off x="381000" y="685800"/>
+            <a:ext cx="6096000" cy="3429000"/>
+          </a:xfrm>
+          <a:custGeom>
+            <a:avLst/>
+            <a:gdLst/>
+            <a:ahLst/>
+            <a:cxnLst/>
+            <a:rect l="l" t="t" r="r" b="b"/>
+            <a:pathLst>
+              <a:path w="120000" h="120000" extrusionOk="0">
+                <a:moveTo>
+                  <a:pt x="0" y="0"/>
+                </a:moveTo>
+                <a:lnTo>
+                  <a:pt x="120000" y="0"/>
+                </a:lnTo>
+                <a:lnTo>
+                  <a:pt x="120000" y="120000"/>
+                </a:lnTo>
+                <a:lnTo>
+                  <a:pt x="0" y="120000"/>
+                </a:lnTo>
+                <a:close/>
+              </a:path>
+            </a:pathLst>
+          </a:custGeom>
+        </p:spPr>
+      </p:sp>
+      <p:sp>
+        <p:nvSpPr>
+          <p:cNvPr id="937" name="Google Shape;937;g20f41e19245_0_19:notes"/>
+          <p:cNvSpPr txBox="1">
+            <a:spLocks noGrp="1"/>
+          </p:cNvSpPr>
+          <p:nvPr>
+            <p:ph type="body" idx="1"/>
+          </p:nvPr>
+        </p:nvSpPr>
+        <p:spPr>
+          <a:xfrm>
+            <a:off x="685800" y="4343400"/>
+            <a:ext cx="5486400" cy="4114800"/>
+          </a:xfrm>
+          <a:prstGeom prst="rect">
+            <a:avLst/>
+          </a:prstGeom>
+        </p:spPr>
+        <p:txBody>
+          <a:bodyPr spcFirstLastPara="1" wrap="square" lIns="91425" tIns="91425" rIns="91425" bIns="91425" anchor="t" anchorCtr="0">
+            <a:noAutofit/>
+          </a:bodyPr>
+          <a:lstStyle/>
+          <a:p>
+            <a:pPr marL="0" lvl="0" indent="0" algn="l" rtl="0">
+              <a:spcBef>
+                <a:spcPts val="0"/>
+              </a:spcBef>
+              <a:spcAft>
+                <a:spcPts val="0"/>
+              </a:spcAft>
+              <a:buNone/>
+            </a:pPr>
+            <a:endParaRPr/>
+          </a:p>
+        </p:txBody>
+      </p:sp>
+    </p:spTree>
+    <p:extLst>
+      <p:ext uri="{BB962C8B-B14F-4D97-AF65-F5344CB8AC3E}">
+        <p14:creationId xmlns:p14="http://schemas.microsoft.com/office/powerpoint/2010/main" val="3219724460"/>
       </p:ext>
     </p:extLst>
   </p:cSld>
@@ -27266,7 +27596,14 @@
                 <a:latin typeface="Calibri" panose="020F0502020204030204" pitchFamily="34" charset="0"/>
                 <a:cs typeface="Calibri" panose="020F0502020204030204" pitchFamily="34" charset="0"/>
               </a:rPr>
-              <a:t>Хранимые функции</a:t>
+              <a:t>Представление </a:t>
+            </a:r>
+            <a:r>
+              <a:rPr lang="en-US" dirty="0" err="1">
+                <a:latin typeface="Calibri" panose="020F0502020204030204" pitchFamily="34" charset="0"/>
+                <a:cs typeface="Calibri" panose="020F0502020204030204" pitchFamily="34" charset="0"/>
+              </a:rPr>
+              <a:t>equipment_full_info</a:t>
             </a:r>
             <a:endParaRPr dirty="0">
               <a:latin typeface="Calibri" panose="020F0502020204030204" pitchFamily="34" charset="0"/>
@@ -27327,10 +27664,66 @@
           </a:p>
         </p:txBody>
       </p:sp>
+      <p:pic>
+        <p:nvPicPr>
+          <p:cNvPr id="5" name="Рисунок 4">
+            <a:extLst>
+              <a:ext uri="{FF2B5EF4-FFF2-40B4-BE49-F238E27FC236}">
+                <a16:creationId xmlns:a16="http://schemas.microsoft.com/office/drawing/2014/main" id="{2D15A57B-E0D6-4AAE-B2CC-9B919C76652F}"/>
+              </a:ext>
+            </a:extLst>
+          </p:cNvPr>
+          <p:cNvPicPr/>
+          <p:nvPr/>
+        </p:nvPicPr>
+        <p:blipFill>
+          <a:blip r:embed="rId3"/>
+          <a:stretch>
+            <a:fillRect/>
+          </a:stretch>
+        </p:blipFill>
+        <p:spPr>
+          <a:xfrm>
+            <a:off x="720000" y="944805"/>
+            <a:ext cx="5401178" cy="1617794"/>
+          </a:xfrm>
+          <a:prstGeom prst="rect">
+            <a:avLst/>
+          </a:prstGeom>
+        </p:spPr>
+      </p:pic>
+      <p:pic>
+        <p:nvPicPr>
+          <p:cNvPr id="6" name="Рисунок 5">
+            <a:extLst>
+              <a:ext uri="{FF2B5EF4-FFF2-40B4-BE49-F238E27FC236}">
+                <a16:creationId xmlns:a16="http://schemas.microsoft.com/office/drawing/2014/main" id="{8C222C61-A36D-4931-B409-7A04DFB3E94D}"/>
+              </a:ext>
+            </a:extLst>
+          </p:cNvPr>
+          <p:cNvPicPr/>
+          <p:nvPr/>
+        </p:nvPicPr>
+        <p:blipFill>
+          <a:blip r:embed="rId4"/>
+          <a:stretch>
+            <a:fillRect/>
+          </a:stretch>
+        </p:blipFill>
+        <p:spPr>
+          <a:xfrm>
+            <a:off x="788020" y="2697850"/>
+            <a:ext cx="5401178" cy="1508550"/>
+          </a:xfrm>
+          <a:prstGeom prst="rect">
+            <a:avLst/>
+          </a:prstGeom>
+        </p:spPr>
+      </p:pic>
     </p:spTree>
     <p:extLst>
       <p:ext uri="{BB962C8B-B14F-4D97-AF65-F5344CB8AC3E}">
-        <p14:creationId xmlns:p14="http://schemas.microsoft.com/office/powerpoint/2010/main" val="2006681296"/>
+        <p14:creationId xmlns:p14="http://schemas.microsoft.com/office/powerpoint/2010/main" val="3821342265"/>
       </p:ext>
     </p:extLst>
   </p:cSld>
@@ -27450,9 +27843,23 @@
                 <a:latin typeface="Calibri" panose="020F0502020204030204" pitchFamily="34" charset="0"/>
                 <a:cs typeface="Calibri" panose="020F0502020204030204" pitchFamily="34" charset="0"/>
               </a:rPr>
-              <a:t>Представления</a:t>
+              <a:t>Представление </a:t>
             </a:r>
-            <a:endParaRPr dirty="0">
+            <a:r>
+              <a:rPr lang="en-US" dirty="0" err="1">
+                <a:latin typeface="Calibri" panose="020F0502020204030204" pitchFamily="34" charset="0"/>
+                <a:cs typeface="Calibri" panose="020F0502020204030204" pitchFamily="34" charset="0"/>
+              </a:rPr>
+              <a:t>equipment_transfer_history</a:t>
+            </a:r>
+            <a:r>
+              <a:rPr lang="en-US" dirty="0">
+                <a:latin typeface="Calibri" panose="020F0502020204030204" pitchFamily="34" charset="0"/>
+                <a:cs typeface="Calibri" panose="020F0502020204030204" pitchFamily="34" charset="0"/>
+              </a:rPr>
+              <a:t> </a:t>
+            </a:r>
+            <a:endParaRPr lang="ru-RU" dirty="0">
               <a:latin typeface="Calibri" panose="020F0502020204030204" pitchFamily="34" charset="0"/>
               <a:cs typeface="Calibri" panose="020F0502020204030204" pitchFamily="34" charset="0"/>
             </a:endParaRPr>
@@ -27511,10 +27918,66 @@
           </a:p>
         </p:txBody>
       </p:sp>
+      <p:pic>
+        <p:nvPicPr>
+          <p:cNvPr id="8" name="Рисунок 7">
+            <a:extLst>
+              <a:ext uri="{FF2B5EF4-FFF2-40B4-BE49-F238E27FC236}">
+                <a16:creationId xmlns:a16="http://schemas.microsoft.com/office/drawing/2014/main" id="{F7BA0457-93FE-42A8-B8B3-9FBCA1124BA4}"/>
+              </a:ext>
+            </a:extLst>
+          </p:cNvPr>
+          <p:cNvPicPr/>
+          <p:nvPr/>
+        </p:nvPicPr>
+        <p:blipFill>
+          <a:blip r:embed="rId3"/>
+          <a:stretch>
+            <a:fillRect/>
+          </a:stretch>
+        </p:blipFill>
+        <p:spPr>
+          <a:xfrm>
+            <a:off x="720000" y="878355"/>
+            <a:ext cx="5940425" cy="1750695"/>
+          </a:xfrm>
+          <a:prstGeom prst="rect">
+            <a:avLst/>
+          </a:prstGeom>
+        </p:spPr>
+      </p:pic>
+      <p:pic>
+        <p:nvPicPr>
+          <p:cNvPr id="9" name="Рисунок 8">
+            <a:extLst>
+              <a:ext uri="{FF2B5EF4-FFF2-40B4-BE49-F238E27FC236}">
+                <a16:creationId xmlns:a16="http://schemas.microsoft.com/office/drawing/2014/main" id="{D37D9EFE-196D-4EC1-A324-10251F95A971}"/>
+              </a:ext>
+            </a:extLst>
+          </p:cNvPr>
+          <p:cNvPicPr/>
+          <p:nvPr/>
+        </p:nvPicPr>
+        <p:blipFill>
+          <a:blip r:embed="rId4"/>
+          <a:stretch>
+            <a:fillRect/>
+          </a:stretch>
+        </p:blipFill>
+        <p:spPr>
+          <a:xfrm>
+            <a:off x="719999" y="2755621"/>
+            <a:ext cx="5940425" cy="1672590"/>
+          </a:xfrm>
+          <a:prstGeom prst="rect">
+            <a:avLst/>
+          </a:prstGeom>
+        </p:spPr>
+      </p:pic>
     </p:spTree>
     <p:extLst>
       <p:ext uri="{BB962C8B-B14F-4D97-AF65-F5344CB8AC3E}">
-        <p14:creationId xmlns:p14="http://schemas.microsoft.com/office/powerpoint/2010/main" val="3821342265"/>
+        <p14:creationId xmlns:p14="http://schemas.microsoft.com/office/powerpoint/2010/main" val="2725011792"/>
       </p:ext>
     </p:extLst>
   </p:cSld>
@@ -27607,8 +28070,8 @@
         </p:nvSpPr>
         <p:spPr>
           <a:xfrm>
-            <a:off x="720000" y="159275"/>
-            <a:ext cx="7704000" cy="572700"/>
+            <a:off x="475785" y="159275"/>
+            <a:ext cx="8489795" cy="572700"/>
           </a:xfrm>
           <a:prstGeom prst="rect">
             <a:avLst/>
@@ -27634,9 +28097,694 @@
                 <a:latin typeface="Calibri" panose="020F0502020204030204" pitchFamily="34" charset="0"/>
                 <a:cs typeface="Calibri" panose="020F0502020204030204" pitchFamily="34" charset="0"/>
               </a:rPr>
-              <a:t>Хранимые процедуры</a:t>
+              <a:t>Хранимая процедура добавления оборудования</a:t>
             </a:r>
-            <a:endParaRPr dirty="0">
+          </a:p>
+        </p:txBody>
+      </p:sp>
+      <p:sp>
+        <p:nvSpPr>
+          <p:cNvPr id="7" name="Прямоугольник 6">
+            <a:extLst>
+              <a:ext uri="{FF2B5EF4-FFF2-40B4-BE49-F238E27FC236}">
+                <a16:creationId xmlns:a16="http://schemas.microsoft.com/office/drawing/2014/main" id="{1CE6102C-C867-48A8-8897-5479A02F63AD}"/>
+              </a:ext>
+            </a:extLst>
+          </p:cNvPr>
+          <p:cNvSpPr/>
+          <p:nvPr/>
+        </p:nvSpPr>
+        <p:spPr>
+          <a:xfrm>
+            <a:off x="0" y="0"/>
+            <a:ext cx="186095" cy="5143500"/>
+          </a:xfrm>
+          <a:prstGeom prst="rect">
+            <a:avLst/>
+          </a:prstGeom>
+          <a:solidFill>
+            <a:srgbClr val="0172EF"/>
+          </a:solidFill>
+          <a:ln>
+            <a:solidFill>
+              <a:srgbClr val="0172EF"/>
+            </a:solidFill>
+          </a:ln>
+        </p:spPr>
+        <p:style>
+          <a:lnRef idx="2">
+            <a:schemeClr val="dk1"/>
+          </a:lnRef>
+          <a:fillRef idx="1">
+            <a:schemeClr val="lt1"/>
+          </a:fillRef>
+          <a:effectRef idx="0">
+            <a:schemeClr val="dk1"/>
+          </a:effectRef>
+          <a:fontRef idx="minor">
+            <a:schemeClr val="dk1"/>
+          </a:fontRef>
+        </p:style>
+        <p:txBody>
+          <a:bodyPr rtlCol="0" anchor="ctr"/>
+          <a:lstStyle/>
+          <a:p>
+            <a:pPr algn="ctr"/>
+            <a:endParaRPr lang="ru-RU"/>
+          </a:p>
+        </p:txBody>
+      </p:sp>
+      <p:pic>
+        <p:nvPicPr>
+          <p:cNvPr id="5" name="Рисунок 4">
+            <a:extLst>
+              <a:ext uri="{FF2B5EF4-FFF2-40B4-BE49-F238E27FC236}">
+                <a16:creationId xmlns:a16="http://schemas.microsoft.com/office/drawing/2014/main" id="{E46B4DB6-9269-40F4-B79A-522222ABCD9A}"/>
+              </a:ext>
+            </a:extLst>
+          </p:cNvPr>
+          <p:cNvPicPr/>
+          <p:nvPr/>
+        </p:nvPicPr>
+        <p:blipFill>
+          <a:blip r:embed="rId3"/>
+          <a:stretch>
+            <a:fillRect/>
+          </a:stretch>
+        </p:blipFill>
+        <p:spPr>
+          <a:xfrm>
+            <a:off x="806333" y="1050483"/>
+            <a:ext cx="5940425" cy="1630045"/>
+          </a:xfrm>
+          <a:prstGeom prst="rect">
+            <a:avLst/>
+          </a:prstGeom>
+        </p:spPr>
+      </p:pic>
+    </p:spTree>
+    <p:extLst>
+      <p:ext uri="{BB962C8B-B14F-4D97-AF65-F5344CB8AC3E}">
+        <p14:creationId xmlns:p14="http://schemas.microsoft.com/office/powerpoint/2010/main" val="3085683484"/>
+      </p:ext>
+    </p:extLst>
+  </p:cSld>
+  <p:clrMapOvr>
+    <a:masterClrMapping/>
+  </p:clrMapOvr>
+</p:sld>
+</file>
+
+<file path=ppt/slides/slide15.xml><?xml version="1.0" encoding="utf-8"?>
+<p:sld xmlns:a="http://schemas.openxmlformats.org/drawingml/2006/main" xmlns:r="http://schemas.openxmlformats.org/officeDocument/2006/relationships" xmlns:p="http://schemas.openxmlformats.org/presentationml/2006/main">
+  <p:cSld>
+    <p:spTree>
+      <p:nvGrpSpPr>
+        <p:cNvPr id="1" name="Shape 938"/>
+        <p:cNvGrpSpPr/>
+        <p:nvPr/>
+      </p:nvGrpSpPr>
+      <p:grpSpPr>
+        <a:xfrm>
+          <a:off x="0" y="0"/>
+          <a:ext cx="0" cy="0"/>
+          <a:chOff x="0" y="0"/>
+          <a:chExt cx="0" cy="0"/>
+        </a:xfrm>
+      </p:grpSpPr>
+      <p:sp>
+        <p:nvSpPr>
+          <p:cNvPr id="4" name="Прямоугольник 3">
+            <a:extLst>
+              <a:ext uri="{FF2B5EF4-FFF2-40B4-BE49-F238E27FC236}">
+                <a16:creationId xmlns:a16="http://schemas.microsoft.com/office/drawing/2014/main" id="{3F215849-5D34-49C1-83BD-B95E193AD702}"/>
+              </a:ext>
+            </a:extLst>
+          </p:cNvPr>
+          <p:cNvSpPr/>
+          <p:nvPr/>
+        </p:nvSpPr>
+        <p:spPr>
+          <a:xfrm>
+            <a:off x="5933507" y="2775430"/>
+            <a:ext cx="3210493" cy="2368070"/>
+          </a:xfrm>
+          <a:prstGeom prst="rect">
+            <a:avLst/>
+          </a:prstGeom>
+          <a:solidFill>
+            <a:schemeClr val="bg1"/>
+          </a:solidFill>
+          <a:ln>
+            <a:solidFill>
+              <a:schemeClr val="bg1"/>
+            </a:solidFill>
+          </a:ln>
+        </p:spPr>
+        <p:style>
+          <a:lnRef idx="2">
+            <a:schemeClr val="accent1">
+              <a:shade val="50000"/>
+            </a:schemeClr>
+          </a:lnRef>
+          <a:fillRef idx="1">
+            <a:schemeClr val="accent1"/>
+          </a:fillRef>
+          <a:effectRef idx="0">
+            <a:schemeClr val="accent1"/>
+          </a:effectRef>
+          <a:fontRef idx="minor">
+            <a:schemeClr val="lt1"/>
+          </a:fontRef>
+        </p:style>
+        <p:txBody>
+          <a:bodyPr rtlCol="0" anchor="ctr"/>
+          <a:lstStyle/>
+          <a:p>
+            <a:pPr algn="ctr"/>
+            <a:endParaRPr lang="ru-RU"/>
+          </a:p>
+        </p:txBody>
+      </p:sp>
+      <p:sp>
+        <p:nvSpPr>
+          <p:cNvPr id="939" name="Google Shape;939;p38"/>
+          <p:cNvSpPr txBox="1">
+            <a:spLocks noGrp="1"/>
+          </p:cNvSpPr>
+          <p:nvPr>
+            <p:ph type="title"/>
+          </p:nvPr>
+        </p:nvSpPr>
+        <p:spPr>
+          <a:xfrm>
+            <a:off x="475785" y="159275"/>
+            <a:ext cx="8489795" cy="572700"/>
+          </a:xfrm>
+          <a:prstGeom prst="rect">
+            <a:avLst/>
+          </a:prstGeom>
+        </p:spPr>
+        <p:txBody>
+          <a:bodyPr spcFirstLastPara="1" wrap="square" lIns="91425" tIns="91425" rIns="91425" bIns="91425" anchor="t" anchorCtr="0">
+            <a:noAutofit/>
+          </a:bodyPr>
+          <a:lstStyle/>
+          <a:p>
+            <a:pPr marL="0" lvl="0" indent="0" algn="l" rtl="0">
+              <a:spcBef>
+                <a:spcPts val="0"/>
+              </a:spcBef>
+              <a:spcAft>
+                <a:spcPts val="0"/>
+              </a:spcAft>
+              <a:buNone/>
+            </a:pPr>
+            <a:r>
+              <a:rPr lang="ru-RU" sz="2800" dirty="0">
+                <a:latin typeface="Calibri" panose="020F0502020204030204" pitchFamily="34" charset="0"/>
+                <a:cs typeface="Calibri" panose="020F0502020204030204" pitchFamily="34" charset="0"/>
+              </a:rPr>
+              <a:t>Хранимая процедура перемещения оборудования</a:t>
+            </a:r>
+          </a:p>
+        </p:txBody>
+      </p:sp>
+      <p:sp>
+        <p:nvSpPr>
+          <p:cNvPr id="7" name="Прямоугольник 6">
+            <a:extLst>
+              <a:ext uri="{FF2B5EF4-FFF2-40B4-BE49-F238E27FC236}">
+                <a16:creationId xmlns:a16="http://schemas.microsoft.com/office/drawing/2014/main" id="{1CE6102C-C867-48A8-8897-5479A02F63AD}"/>
+              </a:ext>
+            </a:extLst>
+          </p:cNvPr>
+          <p:cNvSpPr/>
+          <p:nvPr/>
+        </p:nvSpPr>
+        <p:spPr>
+          <a:xfrm>
+            <a:off x="0" y="0"/>
+            <a:ext cx="186095" cy="5143500"/>
+          </a:xfrm>
+          <a:prstGeom prst="rect">
+            <a:avLst/>
+          </a:prstGeom>
+          <a:solidFill>
+            <a:srgbClr val="0172EF"/>
+          </a:solidFill>
+          <a:ln>
+            <a:solidFill>
+              <a:srgbClr val="0172EF"/>
+            </a:solidFill>
+          </a:ln>
+        </p:spPr>
+        <p:style>
+          <a:lnRef idx="2">
+            <a:schemeClr val="dk1"/>
+          </a:lnRef>
+          <a:fillRef idx="1">
+            <a:schemeClr val="lt1"/>
+          </a:fillRef>
+          <a:effectRef idx="0">
+            <a:schemeClr val="dk1"/>
+          </a:effectRef>
+          <a:fontRef idx="minor">
+            <a:schemeClr val="dk1"/>
+          </a:fontRef>
+        </p:style>
+        <p:txBody>
+          <a:bodyPr rtlCol="0" anchor="ctr"/>
+          <a:lstStyle/>
+          <a:p>
+            <a:pPr algn="ctr"/>
+            <a:endParaRPr lang="ru-RU"/>
+          </a:p>
+        </p:txBody>
+      </p:sp>
+      <p:pic>
+        <p:nvPicPr>
+          <p:cNvPr id="8" name="Рисунок 7">
+            <a:extLst>
+              <a:ext uri="{FF2B5EF4-FFF2-40B4-BE49-F238E27FC236}">
+                <a16:creationId xmlns:a16="http://schemas.microsoft.com/office/drawing/2014/main" id="{1AAE85BF-F91D-4D64-AB40-08DF565661F7}"/>
+              </a:ext>
+            </a:extLst>
+          </p:cNvPr>
+          <p:cNvPicPr/>
+          <p:nvPr/>
+        </p:nvPicPr>
+        <p:blipFill>
+          <a:blip r:embed="rId3"/>
+          <a:stretch>
+            <a:fillRect/>
+          </a:stretch>
+        </p:blipFill>
+        <p:spPr>
+          <a:xfrm>
+            <a:off x="739426" y="910427"/>
+            <a:ext cx="7371228" cy="3721046"/>
+          </a:xfrm>
+          <a:prstGeom prst="rect">
+            <a:avLst/>
+          </a:prstGeom>
+        </p:spPr>
+      </p:pic>
+    </p:spTree>
+    <p:extLst>
+      <p:ext uri="{BB962C8B-B14F-4D97-AF65-F5344CB8AC3E}">
+        <p14:creationId xmlns:p14="http://schemas.microsoft.com/office/powerpoint/2010/main" val="2573236036"/>
+      </p:ext>
+    </p:extLst>
+  </p:cSld>
+  <p:clrMapOvr>
+    <a:masterClrMapping/>
+  </p:clrMapOvr>
+</p:sld>
+</file>
+
+<file path=ppt/slides/slide16.xml><?xml version="1.0" encoding="utf-8"?>
+<p:sld xmlns:a="http://schemas.openxmlformats.org/drawingml/2006/main" xmlns:r="http://schemas.openxmlformats.org/officeDocument/2006/relationships" xmlns:p="http://schemas.openxmlformats.org/presentationml/2006/main">
+  <p:cSld>
+    <p:spTree>
+      <p:nvGrpSpPr>
+        <p:cNvPr id="1" name="Shape 938"/>
+        <p:cNvGrpSpPr/>
+        <p:nvPr/>
+      </p:nvGrpSpPr>
+      <p:grpSpPr>
+        <a:xfrm>
+          <a:off x="0" y="0"/>
+          <a:ext cx="0" cy="0"/>
+          <a:chOff x="0" y="0"/>
+          <a:chExt cx="0" cy="0"/>
+        </a:xfrm>
+      </p:grpSpPr>
+      <p:sp>
+        <p:nvSpPr>
+          <p:cNvPr id="4" name="Прямоугольник 3">
+            <a:extLst>
+              <a:ext uri="{FF2B5EF4-FFF2-40B4-BE49-F238E27FC236}">
+                <a16:creationId xmlns:a16="http://schemas.microsoft.com/office/drawing/2014/main" id="{3F215849-5D34-49C1-83BD-B95E193AD702}"/>
+              </a:ext>
+            </a:extLst>
+          </p:cNvPr>
+          <p:cNvSpPr/>
+          <p:nvPr/>
+        </p:nvSpPr>
+        <p:spPr>
+          <a:xfrm>
+            <a:off x="5933507" y="2775430"/>
+            <a:ext cx="3210493" cy="2368070"/>
+          </a:xfrm>
+          <a:prstGeom prst="rect">
+            <a:avLst/>
+          </a:prstGeom>
+          <a:solidFill>
+            <a:schemeClr val="bg1"/>
+          </a:solidFill>
+          <a:ln>
+            <a:solidFill>
+              <a:schemeClr val="bg1"/>
+            </a:solidFill>
+          </a:ln>
+        </p:spPr>
+        <p:style>
+          <a:lnRef idx="2">
+            <a:schemeClr val="accent1">
+              <a:shade val="50000"/>
+            </a:schemeClr>
+          </a:lnRef>
+          <a:fillRef idx="1">
+            <a:schemeClr val="accent1"/>
+          </a:fillRef>
+          <a:effectRef idx="0">
+            <a:schemeClr val="accent1"/>
+          </a:effectRef>
+          <a:fontRef idx="minor">
+            <a:schemeClr val="lt1"/>
+          </a:fontRef>
+        </p:style>
+        <p:txBody>
+          <a:bodyPr rtlCol="0" anchor="ctr"/>
+          <a:lstStyle/>
+          <a:p>
+            <a:pPr algn="ctr"/>
+            <a:endParaRPr lang="ru-RU"/>
+          </a:p>
+        </p:txBody>
+      </p:sp>
+      <p:sp>
+        <p:nvSpPr>
+          <p:cNvPr id="939" name="Google Shape;939;p38"/>
+          <p:cNvSpPr txBox="1">
+            <a:spLocks noGrp="1"/>
+          </p:cNvSpPr>
+          <p:nvPr>
+            <p:ph type="title"/>
+          </p:nvPr>
+        </p:nvSpPr>
+        <p:spPr>
+          <a:xfrm>
+            <a:off x="475785" y="159275"/>
+            <a:ext cx="8489795" cy="572700"/>
+          </a:xfrm>
+          <a:prstGeom prst="rect">
+            <a:avLst/>
+          </a:prstGeom>
+        </p:spPr>
+        <p:txBody>
+          <a:bodyPr spcFirstLastPara="1" wrap="square" lIns="91425" tIns="91425" rIns="91425" bIns="91425" anchor="t" anchorCtr="0">
+            <a:noAutofit/>
+          </a:bodyPr>
+          <a:lstStyle/>
+          <a:p>
+            <a:pPr marL="0" lvl="0" indent="0" algn="l" rtl="0">
+              <a:spcBef>
+                <a:spcPts val="0"/>
+              </a:spcBef>
+              <a:spcAft>
+                <a:spcPts val="0"/>
+              </a:spcAft>
+              <a:buNone/>
+            </a:pPr>
+            <a:r>
+              <a:rPr lang="ru-RU" sz="2800" dirty="0">
+                <a:latin typeface="Calibri" panose="020F0502020204030204" pitchFamily="34" charset="0"/>
+                <a:cs typeface="Calibri" panose="020F0502020204030204" pitchFamily="34" charset="0"/>
+              </a:rPr>
+              <a:t>Триггер аудита действий над оборудованием</a:t>
+            </a:r>
+          </a:p>
+        </p:txBody>
+      </p:sp>
+      <p:sp>
+        <p:nvSpPr>
+          <p:cNvPr id="7" name="Прямоугольник 6">
+            <a:extLst>
+              <a:ext uri="{FF2B5EF4-FFF2-40B4-BE49-F238E27FC236}">
+                <a16:creationId xmlns:a16="http://schemas.microsoft.com/office/drawing/2014/main" id="{1CE6102C-C867-48A8-8897-5479A02F63AD}"/>
+              </a:ext>
+            </a:extLst>
+          </p:cNvPr>
+          <p:cNvSpPr/>
+          <p:nvPr/>
+        </p:nvSpPr>
+        <p:spPr>
+          <a:xfrm>
+            <a:off x="0" y="0"/>
+            <a:ext cx="186095" cy="5143500"/>
+          </a:xfrm>
+          <a:prstGeom prst="rect">
+            <a:avLst/>
+          </a:prstGeom>
+          <a:solidFill>
+            <a:srgbClr val="0172EF"/>
+          </a:solidFill>
+          <a:ln>
+            <a:solidFill>
+              <a:srgbClr val="0172EF"/>
+            </a:solidFill>
+          </a:ln>
+        </p:spPr>
+        <p:style>
+          <a:lnRef idx="2">
+            <a:schemeClr val="dk1"/>
+          </a:lnRef>
+          <a:fillRef idx="1">
+            <a:schemeClr val="lt1"/>
+          </a:fillRef>
+          <a:effectRef idx="0">
+            <a:schemeClr val="dk1"/>
+          </a:effectRef>
+          <a:fontRef idx="minor">
+            <a:schemeClr val="dk1"/>
+          </a:fontRef>
+        </p:style>
+        <p:txBody>
+          <a:bodyPr rtlCol="0" anchor="ctr"/>
+          <a:lstStyle/>
+          <a:p>
+            <a:pPr algn="ctr"/>
+            <a:endParaRPr lang="ru-RU"/>
+          </a:p>
+        </p:txBody>
+      </p:sp>
+      <p:pic>
+        <p:nvPicPr>
+          <p:cNvPr id="8" name="Рисунок 7">
+            <a:extLst>
+              <a:ext uri="{FF2B5EF4-FFF2-40B4-BE49-F238E27FC236}">
+                <a16:creationId xmlns:a16="http://schemas.microsoft.com/office/drawing/2014/main" id="{BA677B01-DB3B-4CE4-BDE8-4371B89AE40C}"/>
+              </a:ext>
+            </a:extLst>
+          </p:cNvPr>
+          <p:cNvPicPr>
+            <a:picLocks noChangeAspect="1"/>
+          </p:cNvPicPr>
+          <p:nvPr/>
+        </p:nvPicPr>
+        <p:blipFill>
+          <a:blip r:embed="rId3"/>
+          <a:stretch>
+            <a:fillRect/>
+          </a:stretch>
+        </p:blipFill>
+        <p:spPr>
+          <a:xfrm>
+            <a:off x="566474" y="751355"/>
+            <a:ext cx="4986653" cy="2753518"/>
+          </a:xfrm>
+          <a:prstGeom prst="rect">
+            <a:avLst/>
+          </a:prstGeom>
+        </p:spPr>
+      </p:pic>
+      <p:pic>
+        <p:nvPicPr>
+          <p:cNvPr id="10" name="Рисунок 9">
+            <a:extLst>
+              <a:ext uri="{FF2B5EF4-FFF2-40B4-BE49-F238E27FC236}">
+                <a16:creationId xmlns:a16="http://schemas.microsoft.com/office/drawing/2014/main" id="{D93862D6-9B8B-48E4-8DE2-86D55CC0A730}"/>
+              </a:ext>
+            </a:extLst>
+          </p:cNvPr>
+          <p:cNvPicPr>
+            <a:picLocks noChangeAspect="1"/>
+          </p:cNvPicPr>
+          <p:nvPr/>
+        </p:nvPicPr>
+        <p:blipFill rotWithShape="1">
+          <a:blip r:embed="rId4"/>
+          <a:srcRect l="8078"/>
+          <a:stretch/>
+        </p:blipFill>
+        <p:spPr>
+          <a:xfrm>
+            <a:off x="661639" y="3504873"/>
+            <a:ext cx="4341542" cy="1587929"/>
+          </a:xfrm>
+          <a:prstGeom prst="rect">
+            <a:avLst/>
+          </a:prstGeom>
+        </p:spPr>
+      </p:pic>
+      <p:pic>
+        <p:nvPicPr>
+          <p:cNvPr id="3" name="Рисунок 2">
+            <a:extLst>
+              <a:ext uri="{FF2B5EF4-FFF2-40B4-BE49-F238E27FC236}">
+                <a16:creationId xmlns:a16="http://schemas.microsoft.com/office/drawing/2014/main" id="{4DE8F2BB-2890-4FF2-A4A3-0F3FCE55F152}"/>
+              </a:ext>
+            </a:extLst>
+          </p:cNvPr>
+          <p:cNvPicPr>
+            <a:picLocks noChangeAspect="1"/>
+          </p:cNvPicPr>
+          <p:nvPr/>
+        </p:nvPicPr>
+        <p:blipFill>
+          <a:blip r:embed="rId5"/>
+          <a:stretch>
+            <a:fillRect/>
+          </a:stretch>
+        </p:blipFill>
+        <p:spPr>
+          <a:xfrm>
+            <a:off x="4157346" y="2689796"/>
+            <a:ext cx="4986654" cy="1591393"/>
+          </a:xfrm>
+          <a:prstGeom prst="rect">
+            <a:avLst/>
+          </a:prstGeom>
+        </p:spPr>
+      </p:pic>
+    </p:spTree>
+    <p:extLst>
+      <p:ext uri="{BB962C8B-B14F-4D97-AF65-F5344CB8AC3E}">
+        <p14:creationId xmlns:p14="http://schemas.microsoft.com/office/powerpoint/2010/main" val="1194955018"/>
+      </p:ext>
+    </p:extLst>
+  </p:cSld>
+  <p:clrMapOvr>
+    <a:masterClrMapping/>
+  </p:clrMapOvr>
+</p:sld>
+</file>
+
+<file path=ppt/slides/slide17.xml><?xml version="1.0" encoding="utf-8"?>
+<p:sld xmlns:a="http://schemas.openxmlformats.org/drawingml/2006/main" xmlns:r="http://schemas.openxmlformats.org/officeDocument/2006/relationships" xmlns:p="http://schemas.openxmlformats.org/presentationml/2006/main">
+  <p:cSld>
+    <p:spTree>
+      <p:nvGrpSpPr>
+        <p:cNvPr id="1" name="Shape 938"/>
+        <p:cNvGrpSpPr/>
+        <p:nvPr/>
+      </p:nvGrpSpPr>
+      <p:grpSpPr>
+        <a:xfrm>
+          <a:off x="0" y="0"/>
+          <a:ext cx="0" cy="0"/>
+          <a:chOff x="0" y="0"/>
+          <a:chExt cx="0" cy="0"/>
+        </a:xfrm>
+      </p:grpSpPr>
+      <p:sp>
+        <p:nvSpPr>
+          <p:cNvPr id="4" name="Прямоугольник 3">
+            <a:extLst>
+              <a:ext uri="{FF2B5EF4-FFF2-40B4-BE49-F238E27FC236}">
+                <a16:creationId xmlns:a16="http://schemas.microsoft.com/office/drawing/2014/main" id="{3F215849-5D34-49C1-83BD-B95E193AD702}"/>
+              </a:ext>
+            </a:extLst>
+          </p:cNvPr>
+          <p:cNvSpPr/>
+          <p:nvPr/>
+        </p:nvSpPr>
+        <p:spPr>
+          <a:xfrm>
+            <a:off x="5933507" y="2775430"/>
+            <a:ext cx="3210493" cy="2368070"/>
+          </a:xfrm>
+          <a:prstGeom prst="rect">
+            <a:avLst/>
+          </a:prstGeom>
+          <a:solidFill>
+            <a:schemeClr val="bg1"/>
+          </a:solidFill>
+          <a:ln>
+            <a:solidFill>
+              <a:schemeClr val="bg1"/>
+            </a:solidFill>
+          </a:ln>
+        </p:spPr>
+        <p:style>
+          <a:lnRef idx="2">
+            <a:schemeClr val="accent1">
+              <a:shade val="50000"/>
+            </a:schemeClr>
+          </a:lnRef>
+          <a:fillRef idx="1">
+            <a:schemeClr val="accent1"/>
+          </a:fillRef>
+          <a:effectRef idx="0">
+            <a:schemeClr val="accent1"/>
+          </a:effectRef>
+          <a:fontRef idx="minor">
+            <a:schemeClr val="lt1"/>
+          </a:fontRef>
+        </p:style>
+        <p:txBody>
+          <a:bodyPr rtlCol="0" anchor="ctr"/>
+          <a:lstStyle/>
+          <a:p>
+            <a:pPr algn="ctr"/>
+            <a:endParaRPr lang="ru-RU"/>
+          </a:p>
+        </p:txBody>
+      </p:sp>
+      <p:sp>
+        <p:nvSpPr>
+          <p:cNvPr id="939" name="Google Shape;939;p38"/>
+          <p:cNvSpPr txBox="1">
+            <a:spLocks noGrp="1"/>
+          </p:cNvSpPr>
+          <p:nvPr>
+            <p:ph type="title"/>
+          </p:nvPr>
+        </p:nvSpPr>
+        <p:spPr>
+          <a:xfrm>
+            <a:off x="475785" y="159275"/>
+            <a:ext cx="8489795" cy="572700"/>
+          </a:xfrm>
+          <a:prstGeom prst="rect">
+            <a:avLst/>
+          </a:prstGeom>
+        </p:spPr>
+        <p:txBody>
+          <a:bodyPr spcFirstLastPara="1" wrap="square" lIns="91425" tIns="91425" rIns="91425" bIns="91425" anchor="t" anchorCtr="0">
+            <a:noAutofit/>
+          </a:bodyPr>
+          <a:lstStyle/>
+          <a:p>
+            <a:pPr marL="0" lvl="0" indent="0" algn="l" rtl="0">
+              <a:spcBef>
+                <a:spcPts val="0"/>
+              </a:spcBef>
+              <a:spcAft>
+                <a:spcPts val="0"/>
+              </a:spcAft>
+              <a:buNone/>
+            </a:pPr>
+            <a:r>
+              <a:rPr lang="en-US" sz="2800" dirty="0">
+                <a:latin typeface="Calibri" panose="020F0502020204030204" pitchFamily="34" charset="0"/>
+                <a:cs typeface="Calibri" panose="020F0502020204030204" pitchFamily="34" charset="0"/>
+              </a:rPr>
+              <a:t>ERD</a:t>
+            </a:r>
+            <a:endParaRPr lang="ru-RU" sz="2800" dirty="0">
               <a:latin typeface="Calibri" panose="020F0502020204030204" pitchFamily="34" charset="0"/>
               <a:cs typeface="Calibri" panose="020F0502020204030204" pitchFamily="34" charset="0"/>
             </a:endParaRPr>
@@ -27695,10 +28843,40 @@
           </a:p>
         </p:txBody>
       </p:sp>
+      <p:pic>
+        <p:nvPicPr>
+          <p:cNvPr id="5" name="Рисунок 4">
+            <a:extLst>
+              <a:ext uri="{FF2B5EF4-FFF2-40B4-BE49-F238E27FC236}">
+                <a16:creationId xmlns:a16="http://schemas.microsoft.com/office/drawing/2014/main" id="{B6EFE565-4339-4B51-B1DC-49073713AF40}"/>
+              </a:ext>
+            </a:extLst>
+          </p:cNvPr>
+          <p:cNvPicPr>
+            <a:picLocks noChangeAspect="1"/>
+          </p:cNvPicPr>
+          <p:nvPr/>
+        </p:nvPicPr>
+        <p:blipFill>
+          <a:blip r:embed="rId3"/>
+          <a:stretch>
+            <a:fillRect/>
+          </a:stretch>
+        </p:blipFill>
+        <p:spPr>
+          <a:xfrm>
+            <a:off x="475785" y="731975"/>
+            <a:ext cx="7924800" cy="4330098"/>
+          </a:xfrm>
+          <a:prstGeom prst="rect">
+            <a:avLst/>
+          </a:prstGeom>
+        </p:spPr>
+      </p:pic>
     </p:spTree>
     <p:extLst>
       <p:ext uri="{BB962C8B-B14F-4D97-AF65-F5344CB8AC3E}">
-        <p14:creationId xmlns:p14="http://schemas.microsoft.com/office/powerpoint/2010/main" val="3085683484"/>
+        <p14:creationId xmlns:p14="http://schemas.microsoft.com/office/powerpoint/2010/main" val="3333206147"/>
       </p:ext>
     </p:extLst>
   </p:cSld>
@@ -30505,7 +31683,7 @@
         </p:nvSpPr>
         <p:spPr>
           <a:xfrm>
-            <a:off x="720000" y="445025"/>
+            <a:off x="709709" y="388879"/>
             <a:ext cx="7704000" cy="572700"/>
           </a:xfrm>
           <a:prstGeom prst="rect">
@@ -30997,8 +32175,8 @@
         </p:nvSpPr>
         <p:spPr>
           <a:xfrm>
-            <a:off x="6199159" y="4230987"/>
-            <a:ext cx="742087" cy="369332"/>
+            <a:off x="5501840" y="4232555"/>
+            <a:ext cx="1487748" cy="369332"/>
           </a:xfrm>
           <a:prstGeom prst="rect">
             <a:avLst/>
@@ -31107,7 +32285,7 @@
           <a:p>
             <a:r>
               <a:rPr lang="en-US" dirty="0"/>
-              <a:t>Word</a:t>
+              <a:t>Drizzle ORM</a:t>
             </a:r>
             <a:endParaRPr lang="ru-RU" dirty="0"/>
           </a:p>
@@ -31245,62 +32423,6 @@
       </p:sp>
       <p:pic>
         <p:nvPicPr>
-          <p:cNvPr id="11" name="Picture 8" descr="Picture background">
-            <a:extLst>
-              <a:ext uri="{FF2B5EF4-FFF2-40B4-BE49-F238E27FC236}">
-                <a16:creationId xmlns:a16="http://schemas.microsoft.com/office/drawing/2014/main" id="{AC2C0538-27E8-AEC5-8C3F-1B8AC864EB1F}"/>
-              </a:ext>
-            </a:extLst>
-          </p:cNvPr>
-          <p:cNvPicPr>
-            <a:picLocks noChangeAspect="1" noChangeArrowheads="1"/>
-          </p:cNvPicPr>
-          <p:nvPr/>
-        </p:nvPicPr>
-        <p:blipFill>
-          <a:blip r:embed="rId3">
-            <a:extLst>
-              <a:ext uri="{28A0092B-C50C-407E-A947-70E740481C1C}">
-                <a14:useLocalDpi xmlns:a14="http://schemas.microsoft.com/office/drawing/2010/main" val="0"/>
-              </a:ext>
-            </a:extLst>
-          </a:blip>
-          <a:srcRect/>
-          <a:stretch>
-            <a:fillRect/>
-          </a:stretch>
-        </p:blipFill>
-        <p:spPr bwMode="auto">
-          <a:xfrm>
-            <a:off x="5844302" y="3097625"/>
-            <a:ext cx="1166052" cy="1085323"/>
-          </a:xfrm>
-          <a:prstGeom prst="rect">
-            <a:avLst/>
-          </a:prstGeom>
-          <a:ln>
-            <a:noFill/>
-          </a:ln>
-          <a:effectLst>
-            <a:outerShdw blurRad="292100" dist="139700" dir="2700000" algn="tl" rotWithShape="0">
-              <a:srgbClr val="333333">
-                <a:alpha val="65000"/>
-              </a:srgbClr>
-            </a:outerShdw>
-          </a:effectLst>
-          <a:extLst>
-            <a:ext uri="{909E8E84-426E-40DD-AFC4-6F175D3DCCD1}">
-              <a14:hiddenFill xmlns:a14="http://schemas.microsoft.com/office/drawing/2010/main">
-                <a:solidFill>
-                  <a:srgbClr val="FFFFFF"/>
-                </a:solidFill>
-              </a14:hiddenFill>
-            </a:ext>
-          </a:extLst>
-        </p:spPr>
-      </p:pic>
-      <p:pic>
-        <p:nvPicPr>
           <p:cNvPr id="19" name="Рисунок 18">
             <a:extLst>
               <a:ext uri="{FF2B5EF4-FFF2-40B4-BE49-F238E27FC236}">
@@ -31314,7 +32436,7 @@
           <p:nvPr/>
         </p:nvPicPr>
         <p:blipFill>
-          <a:blip r:embed="rId4"/>
+          <a:blip r:embed="rId3"/>
           <a:stretch>
             <a:fillRect/>
           </a:stretch>
@@ -31344,7 +32466,7 @@
           <p:nvPr/>
         </p:nvPicPr>
         <p:blipFill>
-          <a:blip r:embed="rId5"/>
+          <a:blip r:embed="rId4"/>
           <a:stretch>
             <a:fillRect/>
           </a:stretch>
@@ -31374,7 +32496,7 @@
           <p:nvPr/>
         </p:nvPicPr>
         <p:blipFill>
-          <a:blip r:embed="rId6"/>
+          <a:blip r:embed="rId5"/>
           <a:stretch>
             <a:fillRect/>
           </a:stretch>
@@ -31404,7 +32526,7 @@
           <p:nvPr/>
         </p:nvPicPr>
         <p:blipFill>
-          <a:blip r:embed="rId7"/>
+          <a:blip r:embed="rId6"/>
           <a:stretch>
             <a:fillRect/>
           </a:stretch>
@@ -31413,6 +32535,36 @@
           <a:xfrm>
             <a:off x="2257064" y="2828923"/>
             <a:ext cx="1473689" cy="1473689"/>
+          </a:xfrm>
+          <a:prstGeom prst="rect">
+            <a:avLst/>
+          </a:prstGeom>
+        </p:spPr>
+      </p:pic>
+      <p:pic>
+        <p:nvPicPr>
+          <p:cNvPr id="6" name="Рисунок 5">
+            <a:extLst>
+              <a:ext uri="{FF2B5EF4-FFF2-40B4-BE49-F238E27FC236}">
+                <a16:creationId xmlns:a16="http://schemas.microsoft.com/office/drawing/2014/main" id="{BF555B27-96C9-42C5-8999-A3D2D169E03F}"/>
+              </a:ext>
+            </a:extLst>
+          </p:cNvPr>
+          <p:cNvPicPr>
+            <a:picLocks noChangeAspect="1"/>
+          </p:cNvPicPr>
+          <p:nvPr/>
+        </p:nvPicPr>
+        <p:blipFill>
+          <a:blip r:embed="rId7"/>
+          <a:stretch>
+            <a:fillRect/>
+          </a:stretch>
+        </p:blipFill>
+        <p:spPr>
+          <a:xfrm>
+            <a:off x="5261908" y="2701927"/>
+            <a:ext cx="1727680" cy="1727680"/>
           </a:xfrm>
           <a:prstGeom prst="rect">
             <a:avLst/>

</xml_diff>

<commit_message>
equipment create and lots
</commit_message>
<xml_diff>
--- a/docs/Предзащита.pptx
+++ b/docs/Предзащита.pptx
@@ -27445,10 +27445,10 @@
       </p:sp>
       <p:pic>
         <p:nvPicPr>
-          <p:cNvPr id="3" name="Рисунок 2">
+          <p:cNvPr id="5" name="Рисунок 4">
             <a:extLst>
               <a:ext uri="{FF2B5EF4-FFF2-40B4-BE49-F238E27FC236}">
-                <a16:creationId xmlns:a16="http://schemas.microsoft.com/office/drawing/2014/main" id="{9F2052C3-198A-4ECB-9E0F-5067842010C1}"/>
+                <a16:creationId xmlns:a16="http://schemas.microsoft.com/office/drawing/2014/main" id="{9E4B99CC-173A-4A03-9EC3-8F6C47035FC7}"/>
               </a:ext>
             </a:extLst>
           </p:cNvPr>
@@ -27465,8 +27465,8 @@
         </p:blipFill>
         <p:spPr>
           <a:xfrm>
-            <a:off x="2493169" y="942976"/>
-            <a:ext cx="3936206" cy="3936206"/>
+            <a:off x="2695342" y="973873"/>
+            <a:ext cx="3753315" cy="3753315"/>
           </a:xfrm>
           <a:prstGeom prst="rect">
             <a:avLst/>

</xml_diff>

<commit_message>
fix pz and unit tests
</commit_message>
<xml_diff>
--- a/docs/Предзащита.pptx
+++ b/docs/Предзащита.pptx
@@ -5,7 +5,7 @@
     <p:sldMasterId id="2147483679" r:id="rId1"/>
   </p:sldMasterIdLst>
   <p:notesMasterIdLst>
-    <p:notesMasterId r:id="rId19"/>
+    <p:notesMasterId r:id="rId20"/>
   </p:notesMasterIdLst>
   <p:sldIdLst>
     <p:sldId id="256" r:id="rId2"/>
@@ -19,52 +19,53 @@
     <p:sldId id="313" r:id="rId10"/>
     <p:sldId id="314" r:id="rId11"/>
     <p:sldId id="315" r:id="rId12"/>
-    <p:sldId id="318" r:id="rId13"/>
-    <p:sldId id="319" r:id="rId14"/>
-    <p:sldId id="317" r:id="rId15"/>
-    <p:sldId id="320" r:id="rId16"/>
-    <p:sldId id="321" r:id="rId17"/>
-    <p:sldId id="322" r:id="rId18"/>
+    <p:sldId id="323" r:id="rId13"/>
+    <p:sldId id="318" r:id="rId14"/>
+    <p:sldId id="319" r:id="rId15"/>
+    <p:sldId id="317" r:id="rId16"/>
+    <p:sldId id="320" r:id="rId17"/>
+    <p:sldId id="321" r:id="rId18"/>
+    <p:sldId id="322" r:id="rId19"/>
   </p:sldIdLst>
   <p:sldSz cx="9144000" cy="5143500" type="screen16x9"/>
   <p:notesSz cx="6858000" cy="9144000"/>
   <p:embeddedFontLst>
     <p:embeddedFont>
       <p:font typeface="Calibri" panose="020F0502020204030204" pitchFamily="34" charset="0"/>
-      <p:regular r:id="rId20"/>
-      <p:bold r:id="rId21"/>
-      <p:italic r:id="rId22"/>
-      <p:boldItalic r:id="rId23"/>
+      <p:regular r:id="rId21"/>
+      <p:bold r:id="rId22"/>
+      <p:italic r:id="rId23"/>
+      <p:boldItalic r:id="rId24"/>
     </p:embeddedFont>
     <p:embeddedFont>
       <p:font typeface="Figtree" panose="020B0604020202020204" charset="0"/>
-      <p:regular r:id="rId24"/>
-      <p:bold r:id="rId25"/>
-      <p:italic r:id="rId26"/>
-      <p:boldItalic r:id="rId27"/>
+      <p:regular r:id="rId25"/>
+      <p:bold r:id="rId26"/>
+      <p:italic r:id="rId27"/>
+      <p:boldItalic r:id="rId28"/>
     </p:embeddedFont>
     <p:embeddedFont>
       <p:font typeface="Lato" panose="020F0502020204030203" pitchFamily="34" charset="0"/>
-      <p:regular r:id="rId28"/>
-      <p:bold r:id="rId29"/>
-      <p:italic r:id="rId30"/>
-      <p:boldItalic r:id="rId31"/>
+      <p:regular r:id="rId29"/>
+      <p:bold r:id="rId30"/>
+      <p:italic r:id="rId31"/>
+      <p:boldItalic r:id="rId32"/>
     </p:embeddedFont>
     <p:embeddedFont>
       <p:font typeface="Open Sans" panose="020B0606030504020204" pitchFamily="34" charset="0"/>
-      <p:regular r:id="rId32"/>
-      <p:bold r:id="rId33"/>
-      <p:italic r:id="rId34"/>
-      <p:boldItalic r:id="rId35"/>
+      <p:regular r:id="rId33"/>
+      <p:bold r:id="rId34"/>
+      <p:italic r:id="rId35"/>
+      <p:boldItalic r:id="rId36"/>
     </p:embeddedFont>
     <p:embeddedFont>
       <p:font typeface="Sora" panose="020B0604020202020204" charset="0"/>
-      <p:regular r:id="rId36"/>
-      <p:bold r:id="rId37"/>
+      <p:regular r:id="rId37"/>
+      <p:bold r:id="rId38"/>
     </p:embeddedFont>
     <p:embeddedFont>
       <p:font typeface="Sora ExtraBold" panose="020B0604020202020204" charset="0"/>
-      <p:bold r:id="rId38"/>
+      <p:bold r:id="rId39"/>
     </p:embeddedFont>
   </p:embeddedFontLst>
   <p:defaultTextStyle>
@@ -1177,7 +1178,7 @@
     </p:spTree>
     <p:extLst>
       <p:ext uri="{BB962C8B-B14F-4D97-AF65-F5344CB8AC3E}">
-        <p14:creationId xmlns:p14="http://schemas.microsoft.com/office/powerpoint/2010/main" val="664003728"/>
+        <p14:creationId xmlns:p14="http://schemas.microsoft.com/office/powerpoint/2010/main" val="426990434"/>
       </p:ext>
     </p:extLst>
   </p:cSld>
@@ -1286,7 +1287,7 @@
     </p:spTree>
     <p:extLst>
       <p:ext uri="{BB962C8B-B14F-4D97-AF65-F5344CB8AC3E}">
-        <p14:creationId xmlns:p14="http://schemas.microsoft.com/office/powerpoint/2010/main" val="1577733956"/>
+        <p14:creationId xmlns:p14="http://schemas.microsoft.com/office/powerpoint/2010/main" val="664003728"/>
       </p:ext>
     </p:extLst>
   </p:cSld>
@@ -1395,7 +1396,7 @@
     </p:spTree>
     <p:extLst>
       <p:ext uri="{BB962C8B-B14F-4D97-AF65-F5344CB8AC3E}">
-        <p14:creationId xmlns:p14="http://schemas.microsoft.com/office/powerpoint/2010/main" val="3020110829"/>
+        <p14:creationId xmlns:p14="http://schemas.microsoft.com/office/powerpoint/2010/main" val="1577733956"/>
       </p:ext>
     </p:extLst>
   </p:cSld>
@@ -1504,7 +1505,7 @@
     </p:spTree>
     <p:extLst>
       <p:ext uri="{BB962C8B-B14F-4D97-AF65-F5344CB8AC3E}">
-        <p14:creationId xmlns:p14="http://schemas.microsoft.com/office/powerpoint/2010/main" val="565982437"/>
+        <p14:creationId xmlns:p14="http://schemas.microsoft.com/office/powerpoint/2010/main" val="3020110829"/>
       </p:ext>
     </p:extLst>
   </p:cSld>
@@ -1613,6 +1614,115 @@
     </p:spTree>
     <p:extLst>
       <p:ext uri="{BB962C8B-B14F-4D97-AF65-F5344CB8AC3E}">
+        <p14:creationId xmlns:p14="http://schemas.microsoft.com/office/powerpoint/2010/main" val="565982437"/>
+      </p:ext>
+    </p:extLst>
+  </p:cSld>
+  <p:clrMapOvr>
+    <a:masterClrMapping/>
+  </p:clrMapOvr>
+</p:notes>
+</file>
+
+<file path=ppt/notesSlides/notesSlide17.xml><?xml version="1.0" encoding="utf-8"?>
+<p:notes xmlns:a="http://schemas.openxmlformats.org/drawingml/2006/main" xmlns:r="http://schemas.openxmlformats.org/officeDocument/2006/relationships" xmlns:p="http://schemas.openxmlformats.org/presentationml/2006/main" showMasterSp="0" showMasterPhAnim="0">
+  <p:cSld>
+    <p:spTree>
+      <p:nvGrpSpPr>
+        <p:cNvPr id="1" name="Shape 935"/>
+        <p:cNvGrpSpPr/>
+        <p:nvPr/>
+      </p:nvGrpSpPr>
+      <p:grpSpPr>
+        <a:xfrm>
+          <a:off x="0" y="0"/>
+          <a:ext cx="0" cy="0"/>
+          <a:chOff x="0" y="0"/>
+          <a:chExt cx="0" cy="0"/>
+        </a:xfrm>
+      </p:grpSpPr>
+      <p:sp>
+        <p:nvSpPr>
+          <p:cNvPr id="936" name="Google Shape;936;g20f41e19245_0_19:notes"/>
+          <p:cNvSpPr>
+            <a:spLocks noGrp="1" noRot="1" noChangeAspect="1"/>
+          </p:cNvSpPr>
+          <p:nvPr>
+            <p:ph type="sldImg" idx="2"/>
+          </p:nvPr>
+        </p:nvSpPr>
+        <p:spPr>
+          <a:xfrm>
+            <a:off x="381000" y="685800"/>
+            <a:ext cx="6096000" cy="3429000"/>
+          </a:xfrm>
+          <a:custGeom>
+            <a:avLst/>
+            <a:gdLst/>
+            <a:ahLst/>
+            <a:cxnLst/>
+            <a:rect l="l" t="t" r="r" b="b"/>
+            <a:pathLst>
+              <a:path w="120000" h="120000" extrusionOk="0">
+                <a:moveTo>
+                  <a:pt x="0" y="0"/>
+                </a:moveTo>
+                <a:lnTo>
+                  <a:pt x="120000" y="0"/>
+                </a:lnTo>
+                <a:lnTo>
+                  <a:pt x="120000" y="120000"/>
+                </a:lnTo>
+                <a:lnTo>
+                  <a:pt x="0" y="120000"/>
+                </a:lnTo>
+                <a:close/>
+              </a:path>
+            </a:pathLst>
+          </a:custGeom>
+        </p:spPr>
+      </p:sp>
+      <p:sp>
+        <p:nvSpPr>
+          <p:cNvPr id="937" name="Google Shape;937;g20f41e19245_0_19:notes"/>
+          <p:cNvSpPr txBox="1">
+            <a:spLocks noGrp="1"/>
+          </p:cNvSpPr>
+          <p:nvPr>
+            <p:ph type="body" idx="1"/>
+          </p:nvPr>
+        </p:nvSpPr>
+        <p:spPr>
+          <a:xfrm>
+            <a:off x="685800" y="4343400"/>
+            <a:ext cx="5486400" cy="4114800"/>
+          </a:xfrm>
+          <a:prstGeom prst="rect">
+            <a:avLst/>
+          </a:prstGeom>
+        </p:spPr>
+        <p:txBody>
+          <a:bodyPr spcFirstLastPara="1" wrap="square" lIns="91425" tIns="91425" rIns="91425" bIns="91425" anchor="t" anchorCtr="0">
+            <a:noAutofit/>
+          </a:bodyPr>
+          <a:lstStyle/>
+          <a:p>
+            <a:pPr marL="0" lvl="0" indent="0" algn="l" rtl="0">
+              <a:spcBef>
+                <a:spcPts val="0"/>
+              </a:spcBef>
+              <a:spcAft>
+                <a:spcPts val="0"/>
+              </a:spcAft>
+              <a:buNone/>
+            </a:pPr>
+            <a:endParaRPr/>
+          </a:p>
+        </p:txBody>
+      </p:sp>
+    </p:spTree>
+    <p:extLst>
+      <p:ext uri="{BB962C8B-B14F-4D97-AF65-F5344CB8AC3E}">
         <p14:creationId xmlns:p14="http://schemas.microsoft.com/office/powerpoint/2010/main" val="3112489065"/>
       </p:ext>
     </p:extLst>
@@ -1623,7 +1733,7 @@
 </p:notes>
 </file>
 
-<file path=ppt/notesSlides/notesSlide17.xml><?xml version="1.0" encoding="utf-8"?>
+<file path=ppt/notesSlides/notesSlide18.xml><?xml version="1.0" encoding="utf-8"?>
 <p:notes xmlns:a="http://schemas.openxmlformats.org/drawingml/2006/main" xmlns:r="http://schemas.openxmlformats.org/officeDocument/2006/relationships" xmlns:p="http://schemas.openxmlformats.org/presentationml/2006/main" showMasterSp="0" showMasterPhAnim="0">
   <p:cSld>
     <p:spTree>
@@ -27232,10 +27342,10 @@
       </p:sp>
       <p:pic>
         <p:nvPicPr>
-          <p:cNvPr id="5" name="Рисунок 4">
+          <p:cNvPr id="8" name="Рисунок 7">
             <a:extLst>
               <a:ext uri="{FF2B5EF4-FFF2-40B4-BE49-F238E27FC236}">
-                <a16:creationId xmlns:a16="http://schemas.microsoft.com/office/drawing/2014/main" id="{7D4770C7-4F47-463C-AED9-E7D277DEEE3D}"/>
+                <a16:creationId xmlns:a16="http://schemas.microsoft.com/office/drawing/2014/main" id="{4BE6CD38-BCE9-486A-A679-AE04738705C4}"/>
               </a:ext>
             </a:extLst>
           </p:cNvPr>
@@ -27244,15 +27354,16 @@
           </p:cNvPicPr>
           <p:nvPr/>
         </p:nvPicPr>
-        <p:blipFill rotWithShape="1">
+        <p:blipFill>
           <a:blip r:embed="rId3"/>
-          <a:srcRect r="1333"/>
-          <a:stretch/>
+          <a:stretch>
+            <a:fillRect/>
+          </a:stretch>
         </p:blipFill>
         <p:spPr>
           <a:xfrm>
-            <a:off x="871537" y="788707"/>
-            <a:ext cx="7704001" cy="4267655"/>
+            <a:off x="720000" y="795756"/>
+            <a:ext cx="8185954" cy="3551988"/>
           </a:xfrm>
           <a:prstGeom prst="rect">
             <a:avLst/>
@@ -27603,9 +27714,9 @@
                 <a:latin typeface="Calibri" panose="020F0502020204030204" pitchFamily="34" charset="0"/>
                 <a:cs typeface="Calibri" panose="020F0502020204030204" pitchFamily="34" charset="0"/>
               </a:rPr>
-              <a:t>equipment_full_info</a:t>
+              <a:t>equipment_by_room</a:t>
             </a:r>
-            <a:endParaRPr dirty="0">
+            <a:endParaRPr lang="ru-RU" dirty="0">
               <a:latin typeface="Calibri" panose="020F0502020204030204" pitchFamily="34" charset="0"/>
               <a:cs typeface="Calibri" panose="020F0502020204030204" pitchFamily="34" charset="0"/>
             </a:endParaRPr>
@@ -27666,10 +27777,10 @@
       </p:sp>
       <p:pic>
         <p:nvPicPr>
-          <p:cNvPr id="5" name="Рисунок 4">
+          <p:cNvPr id="8" name="Рисунок 7">
             <a:extLst>
               <a:ext uri="{FF2B5EF4-FFF2-40B4-BE49-F238E27FC236}">
-                <a16:creationId xmlns:a16="http://schemas.microsoft.com/office/drawing/2014/main" id="{2D15A57B-E0D6-4AAE-B2CC-9B919C76652F}"/>
+                <a16:creationId xmlns:a16="http://schemas.microsoft.com/office/drawing/2014/main" id="{E4E6E723-609F-4DFE-B6AC-1D886C7A7DA0}"/>
               </a:ext>
             </a:extLst>
           </p:cNvPr>
@@ -27684,8 +27795,8 @@
         </p:blipFill>
         <p:spPr>
           <a:xfrm>
-            <a:off x="720000" y="944805"/>
-            <a:ext cx="5401178" cy="1617794"/>
+            <a:off x="777874" y="731975"/>
+            <a:ext cx="5459820" cy="2368070"/>
           </a:xfrm>
           <a:prstGeom prst="rect">
             <a:avLst/>
@@ -27694,10 +27805,10 @@
       </p:pic>
       <p:pic>
         <p:nvPicPr>
-          <p:cNvPr id="6" name="Рисунок 5">
+          <p:cNvPr id="9" name="Рисунок 8">
             <a:extLst>
               <a:ext uri="{FF2B5EF4-FFF2-40B4-BE49-F238E27FC236}">
-                <a16:creationId xmlns:a16="http://schemas.microsoft.com/office/drawing/2014/main" id="{8C222C61-A36D-4931-B409-7A04DFB3E94D}"/>
+                <a16:creationId xmlns:a16="http://schemas.microsoft.com/office/drawing/2014/main" id="{C91DC291-D4FD-49CA-90E8-3F5635E617B9}"/>
               </a:ext>
             </a:extLst>
           </p:cNvPr>
@@ -27712,8 +27823,8 @@
         </p:blipFill>
         <p:spPr>
           <a:xfrm>
-            <a:off x="788020" y="2697850"/>
-            <a:ext cx="5401178" cy="1508550"/>
+            <a:off x="777874" y="3256280"/>
+            <a:ext cx="6202045" cy="1277620"/>
           </a:xfrm>
           <a:prstGeom prst="rect">
             <a:avLst/>
@@ -27723,7 +27834,7 @@
     </p:spTree>
     <p:extLst>
       <p:ext uri="{BB962C8B-B14F-4D97-AF65-F5344CB8AC3E}">
-        <p14:creationId xmlns:p14="http://schemas.microsoft.com/office/powerpoint/2010/main" val="3821342265"/>
+        <p14:creationId xmlns:p14="http://schemas.microsoft.com/office/powerpoint/2010/main" val="2378174500"/>
       </p:ext>
     </p:extLst>
   </p:cSld>
@@ -27850,16 +27961,9 @@
                 <a:latin typeface="Calibri" panose="020F0502020204030204" pitchFamily="34" charset="0"/>
                 <a:cs typeface="Calibri" panose="020F0502020204030204" pitchFamily="34" charset="0"/>
               </a:rPr>
-              <a:t>equipment_transfer_history</a:t>
+              <a:t>equipment_status_stats</a:t>
             </a:r>
-            <a:r>
-              <a:rPr lang="en-US" dirty="0">
-                <a:latin typeface="Calibri" panose="020F0502020204030204" pitchFamily="34" charset="0"/>
-                <a:cs typeface="Calibri" panose="020F0502020204030204" pitchFamily="34" charset="0"/>
-              </a:rPr>
-              <a:t> </a:t>
-            </a:r>
-            <a:endParaRPr lang="ru-RU" dirty="0">
+            <a:endParaRPr dirty="0">
               <a:latin typeface="Calibri" panose="020F0502020204030204" pitchFamily="34" charset="0"/>
               <a:cs typeface="Calibri" panose="020F0502020204030204" pitchFamily="34" charset="0"/>
             </a:endParaRPr>
@@ -27920,10 +28024,10 @@
       </p:sp>
       <p:pic>
         <p:nvPicPr>
-          <p:cNvPr id="8" name="Рисунок 7">
+          <p:cNvPr id="9" name="Рисунок 8">
             <a:extLst>
               <a:ext uri="{FF2B5EF4-FFF2-40B4-BE49-F238E27FC236}">
-                <a16:creationId xmlns:a16="http://schemas.microsoft.com/office/drawing/2014/main" id="{F7BA0457-93FE-42A8-B8B3-9FBCA1124BA4}"/>
+                <a16:creationId xmlns:a16="http://schemas.microsoft.com/office/drawing/2014/main" id="{B07ED0CF-4A1E-4212-A23D-23516ADED03F}"/>
               </a:ext>
             </a:extLst>
           </p:cNvPr>
@@ -27938,8 +28042,8 @@
         </p:blipFill>
         <p:spPr>
           <a:xfrm>
-            <a:off x="720000" y="878355"/>
-            <a:ext cx="5940425" cy="1750695"/>
+            <a:off x="788020" y="958210"/>
+            <a:ext cx="5096510" cy="1371600"/>
           </a:xfrm>
           <a:prstGeom prst="rect">
             <a:avLst/>
@@ -27948,10 +28052,10 @@
       </p:pic>
       <p:pic>
         <p:nvPicPr>
-          <p:cNvPr id="9" name="Рисунок 8">
+          <p:cNvPr id="10" name="Рисунок 9">
             <a:extLst>
               <a:ext uri="{FF2B5EF4-FFF2-40B4-BE49-F238E27FC236}">
-                <a16:creationId xmlns:a16="http://schemas.microsoft.com/office/drawing/2014/main" id="{D37D9EFE-196D-4EC1-A324-10251F95A971}"/>
+                <a16:creationId xmlns:a16="http://schemas.microsoft.com/office/drawing/2014/main" id="{13F66623-9A44-403D-9DDE-CD9EC42943B7}"/>
               </a:ext>
             </a:extLst>
           </p:cNvPr>
@@ -27966,8 +28070,8 @@
         </p:blipFill>
         <p:spPr>
           <a:xfrm>
-            <a:off x="719999" y="2755621"/>
-            <a:ext cx="5940425" cy="1672590"/>
+            <a:off x="891540" y="2775430"/>
+            <a:ext cx="2667000" cy="752475"/>
           </a:xfrm>
           <a:prstGeom prst="rect">
             <a:avLst/>
@@ -27977,7 +28081,7 @@
     </p:spTree>
     <p:extLst>
       <p:ext uri="{BB962C8B-B14F-4D97-AF65-F5344CB8AC3E}">
-        <p14:creationId xmlns:p14="http://schemas.microsoft.com/office/powerpoint/2010/main" val="2725011792"/>
+        <p14:creationId xmlns:p14="http://schemas.microsoft.com/office/powerpoint/2010/main" val="3821342265"/>
       </p:ext>
     </p:extLst>
   </p:cSld>
@@ -28070,8 +28174,8 @@
         </p:nvSpPr>
         <p:spPr>
           <a:xfrm>
-            <a:off x="475785" y="159275"/>
-            <a:ext cx="8489795" cy="572700"/>
+            <a:off x="720000" y="159275"/>
+            <a:ext cx="7704000" cy="572700"/>
           </a:xfrm>
           <a:prstGeom prst="rect">
             <a:avLst/>
@@ -28097,8 +28201,19 @@
                 <a:latin typeface="Calibri" panose="020F0502020204030204" pitchFamily="34" charset="0"/>
                 <a:cs typeface="Calibri" panose="020F0502020204030204" pitchFamily="34" charset="0"/>
               </a:rPr>
-              <a:t>Хранимая процедура добавления оборудования</a:t>
+              <a:t>Представление </a:t>
             </a:r>
+            <a:r>
+              <a:rPr lang="en-US" dirty="0" err="1">
+                <a:latin typeface="Calibri" panose="020F0502020204030204" pitchFamily="34" charset="0"/>
+                <a:cs typeface="Calibri" panose="020F0502020204030204" pitchFamily="34" charset="0"/>
+              </a:rPr>
+              <a:t>equipment_by_type</a:t>
+            </a:r>
+            <a:endParaRPr lang="ru-RU" dirty="0">
+              <a:latin typeface="Calibri" panose="020F0502020204030204" pitchFamily="34" charset="0"/>
+              <a:cs typeface="Calibri" panose="020F0502020204030204" pitchFamily="34" charset="0"/>
+            </a:endParaRPr>
           </a:p>
         </p:txBody>
       </p:sp>
@@ -28156,10 +28271,10 @@
       </p:sp>
       <p:pic>
         <p:nvPicPr>
-          <p:cNvPr id="5" name="Рисунок 4">
+          <p:cNvPr id="10" name="Рисунок 9">
             <a:extLst>
               <a:ext uri="{FF2B5EF4-FFF2-40B4-BE49-F238E27FC236}">
-                <a16:creationId xmlns:a16="http://schemas.microsoft.com/office/drawing/2014/main" id="{E46B4DB6-9269-40F4-B79A-522222ABCD9A}"/>
+                <a16:creationId xmlns:a16="http://schemas.microsoft.com/office/drawing/2014/main" id="{C1974319-FFDD-4154-A123-1A0A5518310D}"/>
               </a:ext>
             </a:extLst>
           </p:cNvPr>
@@ -28174,8 +28289,36 @@
         </p:blipFill>
         <p:spPr>
           <a:xfrm>
-            <a:off x="806333" y="1050483"/>
-            <a:ext cx="5940425" cy="1630045"/>
+            <a:off x="719999" y="751784"/>
+            <a:ext cx="5942330" cy="2475865"/>
+          </a:xfrm>
+          <a:prstGeom prst="rect">
+            <a:avLst/>
+          </a:prstGeom>
+        </p:spPr>
+      </p:pic>
+      <p:pic>
+        <p:nvPicPr>
+          <p:cNvPr id="12" name="Рисунок 11">
+            <a:extLst>
+              <a:ext uri="{FF2B5EF4-FFF2-40B4-BE49-F238E27FC236}">
+                <a16:creationId xmlns:a16="http://schemas.microsoft.com/office/drawing/2014/main" id="{B448DA3B-9EAC-442E-BFCC-CB0350B9F2EB}"/>
+              </a:ext>
+            </a:extLst>
+          </p:cNvPr>
+          <p:cNvPicPr/>
+          <p:nvPr/>
+        </p:nvPicPr>
+        <p:blipFill>
+          <a:blip r:embed="rId4"/>
+          <a:stretch>
+            <a:fillRect/>
+          </a:stretch>
+        </p:blipFill>
+        <p:spPr>
+          <a:xfrm>
+            <a:off x="777874" y="3349568"/>
+            <a:ext cx="6651625" cy="1351971"/>
           </a:xfrm>
           <a:prstGeom prst="rect">
             <a:avLst/>
@@ -28185,7 +28328,7 @@
     </p:spTree>
     <p:extLst>
       <p:ext uri="{BB962C8B-B14F-4D97-AF65-F5344CB8AC3E}">
-        <p14:creationId xmlns:p14="http://schemas.microsoft.com/office/powerpoint/2010/main" val="3085683484"/>
+        <p14:creationId xmlns:p14="http://schemas.microsoft.com/office/powerpoint/2010/main" val="2725011792"/>
       </p:ext>
     </p:extLst>
   </p:cSld>
@@ -28301,11 +28444,11 @@
               <a:buNone/>
             </a:pPr>
             <a:r>
-              <a:rPr lang="ru-RU" sz="2800" dirty="0">
+              <a:rPr lang="ru-RU" dirty="0">
                 <a:latin typeface="Calibri" panose="020F0502020204030204" pitchFamily="34" charset="0"/>
                 <a:cs typeface="Calibri" panose="020F0502020204030204" pitchFamily="34" charset="0"/>
               </a:rPr>
-              <a:t>Хранимая процедура перемещения оборудования</a:t>
+              <a:t>Хранимая функция для поиска дубликатов оборудования</a:t>
             </a:r>
           </a:p>
         </p:txBody>
@@ -28367,7 +28510,7 @@
           <p:cNvPr id="8" name="Рисунок 7">
             <a:extLst>
               <a:ext uri="{FF2B5EF4-FFF2-40B4-BE49-F238E27FC236}">
-                <a16:creationId xmlns:a16="http://schemas.microsoft.com/office/drawing/2014/main" id="{1AAE85BF-F91D-4D64-AB40-08DF565661F7}"/>
+                <a16:creationId xmlns:a16="http://schemas.microsoft.com/office/drawing/2014/main" id="{5B4AC6CF-72C4-42EC-A3FD-22CA2C1CE18F}"/>
               </a:ext>
             </a:extLst>
           </p:cNvPr>
@@ -28382,8 +28525,8 @@
         </p:blipFill>
         <p:spPr>
           <a:xfrm>
-            <a:off x="739426" y="910427"/>
-            <a:ext cx="7371228" cy="3721046"/>
+            <a:off x="594994" y="1455024"/>
+            <a:ext cx="6903085" cy="2827415"/>
           </a:xfrm>
           <a:prstGeom prst="rect">
             <a:avLst/>
@@ -28393,7 +28536,7 @@
     </p:spTree>
     <p:extLst>
       <p:ext uri="{BB962C8B-B14F-4D97-AF65-F5344CB8AC3E}">
-        <p14:creationId xmlns:p14="http://schemas.microsoft.com/office/powerpoint/2010/main" val="2573236036"/>
+        <p14:creationId xmlns:p14="http://schemas.microsoft.com/office/powerpoint/2010/main" val="3085683484"/>
       </p:ext>
     </p:extLst>
   </p:cSld>
@@ -28513,7 +28656,7 @@
                 <a:latin typeface="Calibri" panose="020F0502020204030204" pitchFamily="34" charset="0"/>
                 <a:cs typeface="Calibri" panose="020F0502020204030204" pitchFamily="34" charset="0"/>
               </a:rPr>
-              <a:t>Триггер аудита действий над оборудованием</a:t>
+              <a:t>Хранимая процедура списания оборудования</a:t>
             </a:r>
           </a:p>
         </p:txBody>
@@ -28572,16 +28715,14 @@
       </p:sp>
       <p:pic>
         <p:nvPicPr>
-          <p:cNvPr id="8" name="Рисунок 7">
+          <p:cNvPr id="6" name="Рисунок 5">
             <a:extLst>
               <a:ext uri="{FF2B5EF4-FFF2-40B4-BE49-F238E27FC236}">
-                <a16:creationId xmlns:a16="http://schemas.microsoft.com/office/drawing/2014/main" id="{BA677B01-DB3B-4CE4-BDE8-4371B89AE40C}"/>
+                <a16:creationId xmlns:a16="http://schemas.microsoft.com/office/drawing/2014/main" id="{67BD024F-F67B-4DDD-B6C5-3EB536C72AC6}"/>
               </a:ext>
             </a:extLst>
           </p:cNvPr>
-          <p:cNvPicPr>
-            <a:picLocks noChangeAspect="1"/>
-          </p:cNvPicPr>
+          <p:cNvPicPr/>
           <p:nvPr/>
         </p:nvPicPr>
         <p:blipFill>
@@ -28592,67 +28733,8 @@
         </p:blipFill>
         <p:spPr>
           <a:xfrm>
-            <a:off x="566474" y="751355"/>
-            <a:ext cx="4986653" cy="2753518"/>
-          </a:xfrm>
-          <a:prstGeom prst="rect">
-            <a:avLst/>
-          </a:prstGeom>
-        </p:spPr>
-      </p:pic>
-      <p:pic>
-        <p:nvPicPr>
-          <p:cNvPr id="10" name="Рисунок 9">
-            <a:extLst>
-              <a:ext uri="{FF2B5EF4-FFF2-40B4-BE49-F238E27FC236}">
-                <a16:creationId xmlns:a16="http://schemas.microsoft.com/office/drawing/2014/main" id="{D93862D6-9B8B-48E4-8DE2-86D55CC0A730}"/>
-              </a:ext>
-            </a:extLst>
-          </p:cNvPr>
-          <p:cNvPicPr>
-            <a:picLocks noChangeAspect="1"/>
-          </p:cNvPicPr>
-          <p:nvPr/>
-        </p:nvPicPr>
-        <p:blipFill rotWithShape="1">
-          <a:blip r:embed="rId4"/>
-          <a:srcRect l="8078"/>
-          <a:stretch/>
-        </p:blipFill>
-        <p:spPr>
-          <a:xfrm>
-            <a:off x="661639" y="3504873"/>
-            <a:ext cx="4341542" cy="1587929"/>
-          </a:xfrm>
-          <a:prstGeom prst="rect">
-            <a:avLst/>
-          </a:prstGeom>
-        </p:spPr>
-      </p:pic>
-      <p:pic>
-        <p:nvPicPr>
-          <p:cNvPr id="3" name="Рисунок 2">
-            <a:extLst>
-              <a:ext uri="{FF2B5EF4-FFF2-40B4-BE49-F238E27FC236}">
-                <a16:creationId xmlns:a16="http://schemas.microsoft.com/office/drawing/2014/main" id="{4DE8F2BB-2890-4FF2-A4A3-0F3FCE55F152}"/>
-              </a:ext>
-            </a:extLst>
-          </p:cNvPr>
-          <p:cNvPicPr>
-            <a:picLocks noChangeAspect="1"/>
-          </p:cNvPicPr>
-          <p:nvPr/>
-        </p:nvPicPr>
-        <p:blipFill>
-          <a:blip r:embed="rId5"/>
-          <a:stretch>
-            <a:fillRect/>
-          </a:stretch>
-        </p:blipFill>
-        <p:spPr>
-          <a:xfrm>
-            <a:off x="4157346" y="2689796"/>
-            <a:ext cx="4986654" cy="1591393"/>
+            <a:off x="475785" y="868362"/>
+            <a:ext cx="5942330" cy="3406775"/>
           </a:xfrm>
           <a:prstGeom prst="rect">
             <a:avLst/>
@@ -28662,7 +28744,7 @@
     </p:spTree>
     <p:extLst>
       <p:ext uri="{BB962C8B-B14F-4D97-AF65-F5344CB8AC3E}">
-        <p14:creationId xmlns:p14="http://schemas.microsoft.com/office/powerpoint/2010/main" val="1194955018"/>
+        <p14:creationId xmlns:p14="http://schemas.microsoft.com/office/powerpoint/2010/main" val="2573236036"/>
       </p:ext>
     </p:extLst>
   </p:cSld>
@@ -28778,6 +28860,244 @@
               <a:buNone/>
             </a:pPr>
             <a:r>
+              <a:rPr lang="ru-RU" sz="2800" dirty="0">
+                <a:latin typeface="Calibri" panose="020F0502020204030204" pitchFamily="34" charset="0"/>
+                <a:cs typeface="Calibri" panose="020F0502020204030204" pitchFamily="34" charset="0"/>
+              </a:rPr>
+              <a:t>Триггер перемещения оборудования</a:t>
+            </a:r>
+          </a:p>
+        </p:txBody>
+      </p:sp>
+      <p:sp>
+        <p:nvSpPr>
+          <p:cNvPr id="7" name="Прямоугольник 6">
+            <a:extLst>
+              <a:ext uri="{FF2B5EF4-FFF2-40B4-BE49-F238E27FC236}">
+                <a16:creationId xmlns:a16="http://schemas.microsoft.com/office/drawing/2014/main" id="{1CE6102C-C867-48A8-8897-5479A02F63AD}"/>
+              </a:ext>
+            </a:extLst>
+          </p:cNvPr>
+          <p:cNvSpPr/>
+          <p:nvPr/>
+        </p:nvSpPr>
+        <p:spPr>
+          <a:xfrm>
+            <a:off x="0" y="0"/>
+            <a:ext cx="186095" cy="5143500"/>
+          </a:xfrm>
+          <a:prstGeom prst="rect">
+            <a:avLst/>
+          </a:prstGeom>
+          <a:solidFill>
+            <a:srgbClr val="0172EF"/>
+          </a:solidFill>
+          <a:ln>
+            <a:solidFill>
+              <a:srgbClr val="0172EF"/>
+            </a:solidFill>
+          </a:ln>
+        </p:spPr>
+        <p:style>
+          <a:lnRef idx="2">
+            <a:schemeClr val="dk1"/>
+          </a:lnRef>
+          <a:fillRef idx="1">
+            <a:schemeClr val="lt1"/>
+          </a:fillRef>
+          <a:effectRef idx="0">
+            <a:schemeClr val="dk1"/>
+          </a:effectRef>
+          <a:fontRef idx="minor">
+            <a:schemeClr val="dk1"/>
+          </a:fontRef>
+        </p:style>
+        <p:txBody>
+          <a:bodyPr rtlCol="0" anchor="ctr"/>
+          <a:lstStyle/>
+          <a:p>
+            <a:pPr algn="ctr"/>
+            <a:endParaRPr lang="ru-RU"/>
+          </a:p>
+        </p:txBody>
+      </p:sp>
+      <p:pic>
+        <p:nvPicPr>
+          <p:cNvPr id="9" name="Рисунок 8">
+            <a:extLst>
+              <a:ext uri="{FF2B5EF4-FFF2-40B4-BE49-F238E27FC236}">
+                <a16:creationId xmlns:a16="http://schemas.microsoft.com/office/drawing/2014/main" id="{280B7E79-7F1C-4853-B3CE-0A0A4AAE88D0}"/>
+              </a:ext>
+            </a:extLst>
+          </p:cNvPr>
+          <p:cNvPicPr/>
+          <p:nvPr/>
+        </p:nvPicPr>
+        <p:blipFill>
+          <a:blip r:embed="rId3"/>
+          <a:stretch>
+            <a:fillRect/>
+          </a:stretch>
+        </p:blipFill>
+        <p:spPr>
+          <a:xfrm>
+            <a:off x="775589" y="817609"/>
+            <a:ext cx="5338699" cy="2797319"/>
+          </a:xfrm>
+          <a:prstGeom prst="rect">
+            <a:avLst/>
+          </a:prstGeom>
+        </p:spPr>
+      </p:pic>
+      <p:pic>
+        <p:nvPicPr>
+          <p:cNvPr id="5" name="Рисунок 4">
+            <a:extLst>
+              <a:ext uri="{FF2B5EF4-FFF2-40B4-BE49-F238E27FC236}">
+                <a16:creationId xmlns:a16="http://schemas.microsoft.com/office/drawing/2014/main" id="{C710397B-B7E1-4C05-8DE4-D7B1DABB5F9E}"/>
+              </a:ext>
+            </a:extLst>
+          </p:cNvPr>
+          <p:cNvPicPr>
+            <a:picLocks noChangeAspect="1"/>
+          </p:cNvPicPr>
+          <p:nvPr/>
+        </p:nvPicPr>
+        <p:blipFill>
+          <a:blip r:embed="rId4"/>
+          <a:stretch>
+            <a:fillRect/>
+          </a:stretch>
+        </p:blipFill>
+        <p:spPr>
+          <a:xfrm>
+            <a:off x="2677672" y="2388108"/>
+            <a:ext cx="5862824" cy="799476"/>
+          </a:xfrm>
+          <a:prstGeom prst="rect">
+            <a:avLst/>
+          </a:prstGeom>
+        </p:spPr>
+      </p:pic>
+    </p:spTree>
+    <p:extLst>
+      <p:ext uri="{BB962C8B-B14F-4D97-AF65-F5344CB8AC3E}">
+        <p14:creationId xmlns:p14="http://schemas.microsoft.com/office/powerpoint/2010/main" val="1194955018"/>
+      </p:ext>
+    </p:extLst>
+  </p:cSld>
+  <p:clrMapOvr>
+    <a:masterClrMapping/>
+  </p:clrMapOvr>
+</p:sld>
+</file>
+
+<file path=ppt/slides/slide18.xml><?xml version="1.0" encoding="utf-8"?>
+<p:sld xmlns:a="http://schemas.openxmlformats.org/drawingml/2006/main" xmlns:r="http://schemas.openxmlformats.org/officeDocument/2006/relationships" xmlns:p="http://schemas.openxmlformats.org/presentationml/2006/main">
+  <p:cSld>
+    <p:spTree>
+      <p:nvGrpSpPr>
+        <p:cNvPr id="1" name="Shape 938"/>
+        <p:cNvGrpSpPr/>
+        <p:nvPr/>
+      </p:nvGrpSpPr>
+      <p:grpSpPr>
+        <a:xfrm>
+          <a:off x="0" y="0"/>
+          <a:ext cx="0" cy="0"/>
+          <a:chOff x="0" y="0"/>
+          <a:chExt cx="0" cy="0"/>
+        </a:xfrm>
+      </p:grpSpPr>
+      <p:sp>
+        <p:nvSpPr>
+          <p:cNvPr id="4" name="Прямоугольник 3">
+            <a:extLst>
+              <a:ext uri="{FF2B5EF4-FFF2-40B4-BE49-F238E27FC236}">
+                <a16:creationId xmlns:a16="http://schemas.microsoft.com/office/drawing/2014/main" id="{3F215849-5D34-49C1-83BD-B95E193AD702}"/>
+              </a:ext>
+            </a:extLst>
+          </p:cNvPr>
+          <p:cNvSpPr/>
+          <p:nvPr/>
+        </p:nvSpPr>
+        <p:spPr>
+          <a:xfrm>
+            <a:off x="5933507" y="2775430"/>
+            <a:ext cx="3210493" cy="2368070"/>
+          </a:xfrm>
+          <a:prstGeom prst="rect">
+            <a:avLst/>
+          </a:prstGeom>
+          <a:solidFill>
+            <a:schemeClr val="bg1"/>
+          </a:solidFill>
+          <a:ln>
+            <a:solidFill>
+              <a:schemeClr val="bg1"/>
+            </a:solidFill>
+          </a:ln>
+        </p:spPr>
+        <p:style>
+          <a:lnRef idx="2">
+            <a:schemeClr val="accent1">
+              <a:shade val="50000"/>
+            </a:schemeClr>
+          </a:lnRef>
+          <a:fillRef idx="1">
+            <a:schemeClr val="accent1"/>
+          </a:fillRef>
+          <a:effectRef idx="0">
+            <a:schemeClr val="accent1"/>
+          </a:effectRef>
+          <a:fontRef idx="minor">
+            <a:schemeClr val="lt1"/>
+          </a:fontRef>
+        </p:style>
+        <p:txBody>
+          <a:bodyPr rtlCol="0" anchor="ctr"/>
+          <a:lstStyle/>
+          <a:p>
+            <a:pPr algn="ctr"/>
+            <a:endParaRPr lang="ru-RU"/>
+          </a:p>
+        </p:txBody>
+      </p:sp>
+      <p:sp>
+        <p:nvSpPr>
+          <p:cNvPr id="939" name="Google Shape;939;p38"/>
+          <p:cNvSpPr txBox="1">
+            <a:spLocks noGrp="1"/>
+          </p:cNvSpPr>
+          <p:nvPr>
+            <p:ph type="title"/>
+          </p:nvPr>
+        </p:nvSpPr>
+        <p:spPr>
+          <a:xfrm>
+            <a:off x="475785" y="159275"/>
+            <a:ext cx="8489795" cy="572700"/>
+          </a:xfrm>
+          <a:prstGeom prst="rect">
+            <a:avLst/>
+          </a:prstGeom>
+        </p:spPr>
+        <p:txBody>
+          <a:bodyPr spcFirstLastPara="1" wrap="square" lIns="91425" tIns="91425" rIns="91425" bIns="91425" anchor="t" anchorCtr="0">
+            <a:noAutofit/>
+          </a:bodyPr>
+          <a:lstStyle/>
+          <a:p>
+            <a:pPr marL="0" lvl="0" indent="0" algn="l" rtl="0">
+              <a:spcBef>
+                <a:spcPts val="0"/>
+              </a:spcBef>
+              <a:spcAft>
+                <a:spcPts val="0"/>
+              </a:spcAft>
+              <a:buNone/>
+            </a:pPr>
+            <a:r>
               <a:rPr lang="en-US" sz="2800" dirty="0">
                 <a:latin typeface="Calibri" panose="020F0502020204030204" pitchFamily="34" charset="0"/>
                 <a:cs typeface="Calibri" panose="020F0502020204030204" pitchFamily="34" charset="0"/>
@@ -28845,10 +29165,10 @@
       </p:sp>
       <p:pic>
         <p:nvPicPr>
-          <p:cNvPr id="5" name="Рисунок 4">
+          <p:cNvPr id="3" name="Рисунок 2">
             <a:extLst>
               <a:ext uri="{FF2B5EF4-FFF2-40B4-BE49-F238E27FC236}">
-                <a16:creationId xmlns:a16="http://schemas.microsoft.com/office/drawing/2014/main" id="{B6EFE565-4339-4B51-B1DC-49073713AF40}"/>
+                <a16:creationId xmlns:a16="http://schemas.microsoft.com/office/drawing/2014/main" id="{0EBA510B-407B-4DBB-9915-383702FFDD62}"/>
               </a:ext>
             </a:extLst>
           </p:cNvPr>
@@ -28865,8 +29185,8 @@
         </p:blipFill>
         <p:spPr>
           <a:xfrm>
-            <a:off x="475785" y="731975"/>
-            <a:ext cx="7924800" cy="4330098"/>
+            <a:off x="1026152" y="731975"/>
+            <a:ext cx="7231463" cy="4227387"/>
           </a:xfrm>
           <a:prstGeom prst="rect">
             <a:avLst/>

</xml_diff>